<commit_message>
Version 0.9 of 2025 rules
added v0.9 of the 2025 MVRC-rules. Fixed the Z-fighting problem. added top/bottom visibility rule. added boundingbox-size rule. Other minor improvemtens.
</commit_message>
<xml_diff>
--- a/introduction Auto-scrutineer.pptx
+++ b/introduction Auto-scrutineer.pptx
@@ -5,7 +5,7 @@
     <p:sldMasterId id="2147483648" r:id="rId1"/>
   </p:sldMasterIdLst>
   <p:notesMasterIdLst>
-    <p:notesMasterId r:id="rId16"/>
+    <p:notesMasterId r:id="rId17"/>
   </p:notesMasterIdLst>
   <p:sldIdLst>
     <p:sldId id="257" r:id="rId2"/>
@@ -16,12 +16,13 @@
     <p:sldId id="261" r:id="rId7"/>
     <p:sldId id="263" r:id="rId8"/>
     <p:sldId id="267" r:id="rId9"/>
-    <p:sldId id="269" r:id="rId10"/>
-    <p:sldId id="258" r:id="rId11"/>
-    <p:sldId id="262" r:id="rId12"/>
-    <p:sldId id="265" r:id="rId13"/>
-    <p:sldId id="266" r:id="rId14"/>
-    <p:sldId id="268" r:id="rId15"/>
+    <p:sldId id="274" r:id="rId10"/>
+    <p:sldId id="269" r:id="rId11"/>
+    <p:sldId id="258" r:id="rId12"/>
+    <p:sldId id="262" r:id="rId13"/>
+    <p:sldId id="265" r:id="rId14"/>
+    <p:sldId id="266" r:id="rId15"/>
+    <p:sldId id="268" r:id="rId16"/>
   </p:sldIdLst>
   <p:sldSz cx="12192000" cy="6858000"/>
   <p:notesSz cx="6858000" cy="9144000"/>
@@ -131,13 +132,499 @@
 <file path=ppt/revisionInfo.xml><?xml version="1.0" encoding="utf-8"?>
 <p1510:revInfo xmlns:a="http://schemas.openxmlformats.org/drawingml/2006/main" xmlns:r="http://schemas.openxmlformats.org/officeDocument/2006/relationships" xmlns:p1510="http://schemas.microsoft.com/office/powerpoint/2015/10/main">
   <p1510:revLst>
-    <p1510:client id="{774FEED2-3CC2-4F88-81AF-7575B46E195E}" v="432" dt="2025-01-23T16:54:04.910"/>
+    <p1510:client id="{BB1FF1FC-C545-4D46-8FB0-786C11002C2F}" v="14" dt="2025-03-18T14:27:35.974"/>
   </p1510:revLst>
 </p1510:revInfo>
 </file>
 
 <file path=ppt/changesInfos/changesInfo1.xml><?xml version="1.0" encoding="utf-8"?>
 <pc:chgInfo xmlns:a="http://schemas.openxmlformats.org/drawingml/2006/main" xmlns:r="http://schemas.openxmlformats.org/officeDocument/2006/relationships" xmlns:ac="http://schemas.microsoft.com/office/drawing/2013/main/command" xmlns:pc="http://schemas.microsoft.com/office/powerpoint/2013/main/command">
+  <pc:docChgLst>
+    <pc:chgData name="Christian -" userId="c9558d0526991bde" providerId="LiveId" clId="{BB1FF1FC-C545-4D46-8FB0-786C11002C2F}"/>
+    <pc:docChg chg="undo custSel delSld modSld">
+      <pc:chgData name="Christian -" userId="c9558d0526991bde" providerId="LiveId" clId="{BB1FF1FC-C545-4D46-8FB0-786C11002C2F}" dt="2025-03-31T16:36:34.468" v="2394" actId="1076"/>
+      <pc:docMkLst>
+        <pc:docMk/>
+      </pc:docMkLst>
+      <pc:sldChg chg="addSp delSp modSp mod">
+        <pc:chgData name="Christian -" userId="c9558d0526991bde" providerId="LiveId" clId="{BB1FF1FC-C545-4D46-8FB0-786C11002C2F}" dt="2025-03-31T16:36:34.468" v="2394" actId="1076"/>
+        <pc:sldMkLst>
+          <pc:docMk/>
+          <pc:sldMk cId="2641459554" sldId="258"/>
+        </pc:sldMkLst>
+        <pc:spChg chg="mod">
+          <ac:chgData name="Christian -" userId="c9558d0526991bde" providerId="LiveId" clId="{BB1FF1FC-C545-4D46-8FB0-786C11002C2F}" dt="2025-03-31T16:35:18.061" v="2383" actId="113"/>
+          <ac:spMkLst>
+            <pc:docMk/>
+            <pc:sldMk cId="2641459554" sldId="258"/>
+            <ac:spMk id="7" creationId="{F922F690-3D1D-48B9-91EC-E7104FBC87A4}"/>
+          </ac:spMkLst>
+        </pc:spChg>
+        <pc:spChg chg="mod">
+          <ac:chgData name="Christian -" userId="c9558d0526991bde" providerId="LiveId" clId="{BB1FF1FC-C545-4D46-8FB0-786C11002C2F}" dt="2025-03-31T16:35:48.527" v="2384" actId="1076"/>
+          <ac:spMkLst>
+            <pc:docMk/>
+            <pc:sldMk cId="2641459554" sldId="258"/>
+            <ac:spMk id="8" creationId="{3FA879C3-4732-5FB6-637C-1DB83B0C071D}"/>
+          </ac:spMkLst>
+        </pc:spChg>
+        <pc:spChg chg="mod">
+          <ac:chgData name="Christian -" userId="c9558d0526991bde" providerId="LiveId" clId="{BB1FF1FC-C545-4D46-8FB0-786C11002C2F}" dt="2025-03-31T16:35:52.157" v="2386" actId="1076"/>
+          <ac:spMkLst>
+            <pc:docMk/>
+            <pc:sldMk cId="2641459554" sldId="258"/>
+            <ac:spMk id="14" creationId="{A2CF13DA-42BF-E4E8-1546-CE4D99CD3D18}"/>
+          </ac:spMkLst>
+        </pc:spChg>
+        <pc:picChg chg="add mod">
+          <ac:chgData name="Christian -" userId="c9558d0526991bde" providerId="LiveId" clId="{BB1FF1FC-C545-4D46-8FB0-786C11002C2F}" dt="2025-03-31T16:36:34.468" v="2394" actId="1076"/>
+          <ac:picMkLst>
+            <pc:docMk/>
+            <pc:sldMk cId="2641459554" sldId="258"/>
+            <ac:picMk id="4" creationId="{807453E4-F433-D89C-983C-567CB6849CD5}"/>
+          </ac:picMkLst>
+        </pc:picChg>
+        <pc:picChg chg="mod">
+          <ac:chgData name="Christian -" userId="c9558d0526991bde" providerId="LiveId" clId="{BB1FF1FC-C545-4D46-8FB0-786C11002C2F}" dt="2025-03-31T16:35:49.807" v="2385" actId="1076"/>
+          <ac:picMkLst>
+            <pc:docMk/>
+            <pc:sldMk cId="2641459554" sldId="258"/>
+            <ac:picMk id="5" creationId="{FE14CB72-FF11-5EF5-2D4E-59C0E22E4F4C}"/>
+          </ac:picMkLst>
+        </pc:picChg>
+        <pc:picChg chg="del mod">
+          <ac:chgData name="Christian -" userId="c9558d0526991bde" providerId="LiveId" clId="{BB1FF1FC-C545-4D46-8FB0-786C11002C2F}" dt="2025-03-31T16:36:24.945" v="2388" actId="478"/>
+          <ac:picMkLst>
+            <pc:docMk/>
+            <pc:sldMk cId="2641459554" sldId="258"/>
+            <ac:picMk id="13" creationId="{B79E8409-79ED-3A7E-034F-67AEB824C6E0}"/>
+          </ac:picMkLst>
+        </pc:picChg>
+      </pc:sldChg>
+      <pc:sldChg chg="modSp mod">
+        <pc:chgData name="Christian -" userId="c9558d0526991bde" providerId="LiveId" clId="{BB1FF1FC-C545-4D46-8FB0-786C11002C2F}" dt="2025-03-18T14:29:58.467" v="2116" actId="20577"/>
+        <pc:sldMkLst>
+          <pc:docMk/>
+          <pc:sldMk cId="3035524407" sldId="259"/>
+        </pc:sldMkLst>
+        <pc:spChg chg="mod">
+          <ac:chgData name="Christian -" userId="c9558d0526991bde" providerId="LiveId" clId="{BB1FF1FC-C545-4D46-8FB0-786C11002C2F}" dt="2025-03-18T14:29:58.467" v="2116" actId="20577"/>
+          <ac:spMkLst>
+            <pc:docMk/>
+            <pc:sldMk cId="3035524407" sldId="259"/>
+            <ac:spMk id="3" creationId="{6E7C88EF-E663-3E7E-2FF6-69A53DFF4150}"/>
+          </ac:spMkLst>
+        </pc:spChg>
+      </pc:sldChg>
+      <pc:sldChg chg="delSp modSp mod">
+        <pc:chgData name="Christian -" userId="c9558d0526991bde" providerId="LiveId" clId="{BB1FF1FC-C545-4D46-8FB0-786C11002C2F}" dt="2025-03-31T16:25:12.754" v="2199" actId="113"/>
+        <pc:sldMkLst>
+          <pc:docMk/>
+          <pc:sldMk cId="4086018805" sldId="260"/>
+        </pc:sldMkLst>
+        <pc:spChg chg="mod">
+          <ac:chgData name="Christian -" userId="c9558d0526991bde" providerId="LiveId" clId="{BB1FF1FC-C545-4D46-8FB0-786C11002C2F}" dt="2025-03-31T16:24:47.627" v="2196" actId="20577"/>
+          <ac:spMkLst>
+            <pc:docMk/>
+            <pc:sldMk cId="4086018805" sldId="260"/>
+            <ac:spMk id="3" creationId="{50AD5C1A-395D-C3FC-0975-21CF2034A080}"/>
+          </ac:spMkLst>
+        </pc:spChg>
+        <pc:spChg chg="mod">
+          <ac:chgData name="Christian -" userId="c9558d0526991bde" providerId="LiveId" clId="{BB1FF1FC-C545-4D46-8FB0-786C11002C2F}" dt="2025-03-31T16:25:12.754" v="2199" actId="113"/>
+          <ac:spMkLst>
+            <pc:docMk/>
+            <pc:sldMk cId="4086018805" sldId="260"/>
+            <ac:spMk id="4" creationId="{603813BB-9489-D2AC-9CF0-45218CAF28BC}"/>
+          </ac:spMkLst>
+        </pc:spChg>
+      </pc:sldChg>
+      <pc:sldChg chg="delSp modSp mod">
+        <pc:chgData name="Christian -" userId="c9558d0526991bde" providerId="LiveId" clId="{BB1FF1FC-C545-4D46-8FB0-786C11002C2F}" dt="2025-03-31T16:26:24.281" v="2229" actId="20577"/>
+        <pc:sldMkLst>
+          <pc:docMk/>
+          <pc:sldMk cId="352367978" sldId="261"/>
+        </pc:sldMkLst>
+        <pc:spChg chg="mod">
+          <ac:chgData name="Christian -" userId="c9558d0526991bde" providerId="LiveId" clId="{BB1FF1FC-C545-4D46-8FB0-786C11002C2F}" dt="2025-03-15T16:11:32.018" v="293" actId="20577"/>
+          <ac:spMkLst>
+            <pc:docMk/>
+            <pc:sldMk cId="352367978" sldId="261"/>
+            <ac:spMk id="2" creationId="{D0048704-E0C2-93D2-CA20-3AFBC1D83DE6}"/>
+          </ac:spMkLst>
+        </pc:spChg>
+        <pc:spChg chg="del mod">
+          <ac:chgData name="Christian -" userId="c9558d0526991bde" providerId="LiveId" clId="{BB1FF1FC-C545-4D46-8FB0-786C11002C2F}" dt="2025-03-31T16:25:59.150" v="2200" actId="478"/>
+          <ac:spMkLst>
+            <pc:docMk/>
+            <pc:sldMk cId="352367978" sldId="261"/>
+            <ac:spMk id="3" creationId="{7D8CDBEA-48CD-65F8-C43A-582FB26C3B8B}"/>
+          </ac:spMkLst>
+        </pc:spChg>
+        <pc:spChg chg="mod">
+          <ac:chgData name="Christian -" userId="c9558d0526991bde" providerId="LiveId" clId="{BB1FF1FC-C545-4D46-8FB0-786C11002C2F}" dt="2025-03-31T16:26:24.281" v="2229" actId="20577"/>
+          <ac:spMkLst>
+            <pc:docMk/>
+            <pc:sldMk cId="352367978" sldId="261"/>
+            <ac:spMk id="9" creationId="{4909DEA8-8806-621A-161B-52B869D95191}"/>
+          </ac:spMkLst>
+        </pc:spChg>
+        <pc:picChg chg="del">
+          <ac:chgData name="Christian -" userId="c9558d0526991bde" providerId="LiveId" clId="{BB1FF1FC-C545-4D46-8FB0-786C11002C2F}" dt="2025-03-31T16:25:59.597" v="2201" actId="478"/>
+          <ac:picMkLst>
+            <pc:docMk/>
+            <pc:sldMk cId="352367978" sldId="261"/>
+            <ac:picMk id="18" creationId="{3D586A4B-ADAC-2A41-6BBF-F02F84C9D67D}"/>
+          </ac:picMkLst>
+        </pc:picChg>
+      </pc:sldChg>
+      <pc:sldChg chg="addSp delSp modSp mod">
+        <pc:chgData name="Christian -" userId="c9558d0526991bde" providerId="LiveId" clId="{BB1FF1FC-C545-4D46-8FB0-786C11002C2F}" dt="2025-03-18T14:17:00.567" v="1474" actId="1076"/>
+        <pc:sldMkLst>
+          <pc:docMk/>
+          <pc:sldMk cId="957224097" sldId="262"/>
+        </pc:sldMkLst>
+        <pc:spChg chg="mod">
+          <ac:chgData name="Christian -" userId="c9558d0526991bde" providerId="LiveId" clId="{BB1FF1FC-C545-4D46-8FB0-786C11002C2F}" dt="2025-03-18T14:16:26.454" v="1473" actId="20577"/>
+          <ac:spMkLst>
+            <pc:docMk/>
+            <pc:sldMk cId="957224097" sldId="262"/>
+            <ac:spMk id="3" creationId="{78520EB7-069E-2543-2809-435F13965E4A}"/>
+          </ac:spMkLst>
+        </pc:spChg>
+        <pc:picChg chg="add mod">
+          <ac:chgData name="Christian -" userId="c9558d0526991bde" providerId="LiveId" clId="{BB1FF1FC-C545-4D46-8FB0-786C11002C2F}" dt="2025-03-18T14:17:00.567" v="1474" actId="1076"/>
+          <ac:picMkLst>
+            <pc:docMk/>
+            <pc:sldMk cId="957224097" sldId="262"/>
+            <ac:picMk id="6" creationId="{A98E87B1-CDAC-BE4C-F23C-106B0FAEA59A}"/>
+          </ac:picMkLst>
+        </pc:picChg>
+        <pc:picChg chg="add mod">
+          <ac:chgData name="Christian -" userId="c9558d0526991bde" providerId="LiveId" clId="{BB1FF1FC-C545-4D46-8FB0-786C11002C2F}" dt="2025-03-18T14:15:17.603" v="1402" actId="1076"/>
+          <ac:picMkLst>
+            <pc:docMk/>
+            <pc:sldMk cId="957224097" sldId="262"/>
+            <ac:picMk id="8" creationId="{C4A70F42-F75D-842C-7722-9BA7E08FBCD5}"/>
+          </ac:picMkLst>
+        </pc:picChg>
+      </pc:sldChg>
+      <pc:sldChg chg="modSp mod">
+        <pc:chgData name="Christian -" userId="c9558d0526991bde" providerId="LiveId" clId="{BB1FF1FC-C545-4D46-8FB0-786C11002C2F}" dt="2025-03-31T16:34:45.445" v="2381" actId="113"/>
+        <pc:sldMkLst>
+          <pc:docMk/>
+          <pc:sldMk cId="157072469" sldId="263"/>
+        </pc:sldMkLst>
+        <pc:spChg chg="mod">
+          <ac:chgData name="Christian -" userId="c9558d0526991bde" providerId="LiveId" clId="{BB1FF1FC-C545-4D46-8FB0-786C11002C2F}" dt="2025-03-31T16:34:45.445" v="2381" actId="113"/>
+          <ac:spMkLst>
+            <pc:docMk/>
+            <pc:sldMk cId="157072469" sldId="263"/>
+            <ac:spMk id="3" creationId="{38CBB4E4-08C3-4079-E591-AA8764FF3512}"/>
+          </ac:spMkLst>
+        </pc:spChg>
+      </pc:sldChg>
+      <pc:sldChg chg="addSp modSp mod">
+        <pc:chgData name="Christian -" userId="c9558d0526991bde" providerId="LiveId" clId="{BB1FF1FC-C545-4D46-8FB0-786C11002C2F}" dt="2025-03-16T17:48:05.324" v="498" actId="1076"/>
+        <pc:sldMkLst>
+          <pc:docMk/>
+          <pc:sldMk cId="4141951666" sldId="264"/>
+        </pc:sldMkLst>
+        <pc:spChg chg="mod">
+          <ac:chgData name="Christian -" userId="c9558d0526991bde" providerId="LiveId" clId="{BB1FF1FC-C545-4D46-8FB0-786C11002C2F}" dt="2025-03-16T17:48:05.324" v="498" actId="1076"/>
+          <ac:spMkLst>
+            <pc:docMk/>
+            <pc:sldMk cId="4141951666" sldId="264"/>
+            <ac:spMk id="7" creationId="{8593BA47-3136-F050-2015-01228C8E97DE}"/>
+          </ac:spMkLst>
+        </pc:spChg>
+        <pc:spChg chg="add mod">
+          <ac:chgData name="Christian -" userId="c9558d0526991bde" providerId="LiveId" clId="{BB1FF1FC-C545-4D46-8FB0-786C11002C2F}" dt="2025-03-16T17:36:50.738" v="495" actId="1076"/>
+          <ac:spMkLst>
+            <pc:docMk/>
+            <pc:sldMk cId="4141951666" sldId="264"/>
+            <ac:spMk id="8" creationId="{C8CE1F5D-2BBB-5A93-4178-A32A108373D3}"/>
+          </ac:spMkLst>
+        </pc:spChg>
+      </pc:sldChg>
+      <pc:sldChg chg="modSp mod">
+        <pc:chgData name="Christian -" userId="c9558d0526991bde" providerId="LiveId" clId="{BB1FF1FC-C545-4D46-8FB0-786C11002C2F}" dt="2025-03-18T14:17:21.342" v="1504" actId="404"/>
+        <pc:sldMkLst>
+          <pc:docMk/>
+          <pc:sldMk cId="2475629356" sldId="265"/>
+        </pc:sldMkLst>
+        <pc:spChg chg="mod">
+          <ac:chgData name="Christian -" userId="c9558d0526991bde" providerId="LiveId" clId="{BB1FF1FC-C545-4D46-8FB0-786C11002C2F}" dt="2025-03-18T14:17:21.342" v="1504" actId="404"/>
+          <ac:spMkLst>
+            <pc:docMk/>
+            <pc:sldMk cId="2475629356" sldId="265"/>
+            <ac:spMk id="2" creationId="{46AF3F72-B4E1-6AFE-661D-2F907B54C88F}"/>
+          </ac:spMkLst>
+        </pc:spChg>
+      </pc:sldChg>
+      <pc:sldChg chg="addSp modSp mod">
+        <pc:chgData name="Christian -" userId="c9558d0526991bde" providerId="LiveId" clId="{BB1FF1FC-C545-4D46-8FB0-786C11002C2F}" dt="2025-03-18T14:19:03.771" v="1603" actId="20577"/>
+        <pc:sldMkLst>
+          <pc:docMk/>
+          <pc:sldMk cId="3465952826" sldId="266"/>
+        </pc:sldMkLst>
+        <pc:spChg chg="add mod">
+          <ac:chgData name="Christian -" userId="c9558d0526991bde" providerId="LiveId" clId="{BB1FF1FC-C545-4D46-8FB0-786C11002C2F}" dt="2025-03-18T14:19:03.771" v="1603" actId="20577"/>
+          <ac:spMkLst>
+            <pc:docMk/>
+            <pc:sldMk cId="3465952826" sldId="266"/>
+            <ac:spMk id="6" creationId="{D5C57212-AAF0-07DD-DE0A-208079B394EE}"/>
+          </ac:spMkLst>
+        </pc:spChg>
+        <pc:graphicFrameChg chg="mod">
+          <ac:chgData name="Christian -" userId="c9558d0526991bde" providerId="LiveId" clId="{BB1FF1FC-C545-4D46-8FB0-786C11002C2F}" dt="2025-03-18T14:17:51.281" v="1506" actId="1076"/>
+          <ac:graphicFrameMkLst>
+            <pc:docMk/>
+            <pc:sldMk cId="3465952826" sldId="266"/>
+            <ac:graphicFrameMk id="29" creationId="{B0BE12E7-C4B3-5598-6963-611EB943DA2C}"/>
+          </ac:graphicFrameMkLst>
+        </pc:graphicFrameChg>
+        <pc:cxnChg chg="mod">
+          <ac:chgData name="Christian -" userId="c9558d0526991bde" providerId="LiveId" clId="{BB1FF1FC-C545-4D46-8FB0-786C11002C2F}" dt="2025-03-18T14:18:00.527" v="1511" actId="14100"/>
+          <ac:cxnSpMkLst>
+            <pc:docMk/>
+            <pc:sldMk cId="3465952826" sldId="266"/>
+            <ac:cxnSpMk id="30" creationId="{F1943EA3-F588-F681-CF2F-2356570B2F84}"/>
+          </ac:cxnSpMkLst>
+        </pc:cxnChg>
+        <pc:cxnChg chg="mod">
+          <ac:chgData name="Christian -" userId="c9558d0526991bde" providerId="LiveId" clId="{BB1FF1FC-C545-4D46-8FB0-786C11002C2F}" dt="2025-03-18T14:17:55.380" v="1508" actId="14100"/>
+          <ac:cxnSpMkLst>
+            <pc:docMk/>
+            <pc:sldMk cId="3465952826" sldId="266"/>
+            <ac:cxnSpMk id="32" creationId="{FE9ADFC0-B0A0-5ABD-6319-6A55B82AB567}"/>
+          </ac:cxnSpMkLst>
+        </pc:cxnChg>
+      </pc:sldChg>
+      <pc:sldChg chg="modSp mod">
+        <pc:chgData name="Christian -" userId="c9558d0526991bde" providerId="LiveId" clId="{BB1FF1FC-C545-4D46-8FB0-786C11002C2F}" dt="2025-03-15T16:13:15.187" v="352" actId="20577"/>
+        <pc:sldMkLst>
+          <pc:docMk/>
+          <pc:sldMk cId="214645441" sldId="267"/>
+        </pc:sldMkLst>
+        <pc:spChg chg="mod">
+          <ac:chgData name="Christian -" userId="c9558d0526991bde" providerId="LiveId" clId="{BB1FF1FC-C545-4D46-8FB0-786C11002C2F}" dt="2025-03-15T16:13:15.187" v="352" actId="20577"/>
+          <ac:spMkLst>
+            <pc:docMk/>
+            <pc:sldMk cId="214645441" sldId="267"/>
+            <ac:spMk id="23" creationId="{4A894048-2C83-81A2-0F5A-A1C7BD9827F7}"/>
+          </ac:spMkLst>
+        </pc:spChg>
+      </pc:sldChg>
+      <pc:sldChg chg="modSp mod">
+        <pc:chgData name="Christian -" userId="c9558d0526991bde" providerId="LiveId" clId="{BB1FF1FC-C545-4D46-8FB0-786C11002C2F}" dt="2025-03-18T14:20:25.156" v="1641" actId="20577"/>
+        <pc:sldMkLst>
+          <pc:docMk/>
+          <pc:sldMk cId="2247630597" sldId="268"/>
+        </pc:sldMkLst>
+        <pc:spChg chg="mod">
+          <ac:chgData name="Christian -" userId="c9558d0526991bde" providerId="LiveId" clId="{BB1FF1FC-C545-4D46-8FB0-786C11002C2F}" dt="2025-03-18T14:19:46.964" v="1634" actId="20577"/>
+          <ac:spMkLst>
+            <pc:docMk/>
+            <pc:sldMk cId="2247630597" sldId="268"/>
+            <ac:spMk id="2" creationId="{E3618091-0511-4D2A-281E-DDFAE71743B3}"/>
+          </ac:spMkLst>
+        </pc:spChg>
+        <pc:graphicFrameChg chg="mod">
+          <ac:chgData name="Christian -" userId="c9558d0526991bde" providerId="LiveId" clId="{BB1FF1FC-C545-4D46-8FB0-786C11002C2F}" dt="2025-03-18T14:20:25.156" v="1641" actId="20577"/>
+          <ac:graphicFrameMkLst>
+            <pc:docMk/>
+            <pc:sldMk cId="2247630597" sldId="268"/>
+            <ac:graphicFrameMk id="29" creationId="{5A06D063-3160-D8DF-2322-39F98069A6B8}"/>
+          </ac:graphicFrameMkLst>
+        </pc:graphicFrameChg>
+      </pc:sldChg>
+      <pc:sldChg chg="modSp mod">
+        <pc:chgData name="Christian -" userId="c9558d0526991bde" providerId="LiveId" clId="{BB1FF1FC-C545-4D46-8FB0-786C11002C2F}" dt="2025-03-18T14:10:10.995" v="1166" actId="20577"/>
+        <pc:sldMkLst>
+          <pc:docMk/>
+          <pc:sldMk cId="2522301294" sldId="269"/>
+        </pc:sldMkLst>
+        <pc:spChg chg="mod">
+          <ac:chgData name="Christian -" userId="c9558d0526991bde" providerId="LiveId" clId="{BB1FF1FC-C545-4D46-8FB0-786C11002C2F}" dt="2025-03-18T14:10:10.995" v="1166" actId="20577"/>
+          <ac:spMkLst>
+            <pc:docMk/>
+            <pc:sldMk cId="2522301294" sldId="269"/>
+            <ac:spMk id="3" creationId="{FB6D1EAF-4116-2747-FEE8-2D964FC616C9}"/>
+          </ac:spMkLst>
+        </pc:spChg>
+      </pc:sldChg>
+      <pc:sldChg chg="del">
+        <pc:chgData name="Christian -" userId="c9558d0526991bde" providerId="LiveId" clId="{BB1FF1FC-C545-4D46-8FB0-786C11002C2F}" dt="2025-03-18T14:20:45.863" v="1642" actId="2696"/>
+        <pc:sldMkLst>
+          <pc:docMk/>
+          <pc:sldMk cId="1580336922" sldId="271"/>
+        </pc:sldMkLst>
+      </pc:sldChg>
+      <pc:sldChg chg="del">
+        <pc:chgData name="Christian -" userId="c9558d0526991bde" providerId="LiveId" clId="{BB1FF1FC-C545-4D46-8FB0-786C11002C2F}" dt="2025-03-18T14:20:49.940" v="1643" actId="2696"/>
+        <pc:sldMkLst>
+          <pc:docMk/>
+          <pc:sldMk cId="1566502231" sldId="272"/>
+        </pc:sldMkLst>
+      </pc:sldChg>
+      <pc:sldChg chg="del">
+        <pc:chgData name="Christian -" userId="c9558d0526991bde" providerId="LiveId" clId="{BB1FF1FC-C545-4D46-8FB0-786C11002C2F}" dt="2025-03-15T16:09:34.598" v="282" actId="2696"/>
+        <pc:sldMkLst>
+          <pc:docMk/>
+          <pc:sldMk cId="2923521188" sldId="273"/>
+        </pc:sldMkLst>
+      </pc:sldChg>
+      <pc:sldChg chg="addSp modSp mod">
+        <pc:chgData name="Christian -" userId="c9558d0526991bde" providerId="LiveId" clId="{BB1FF1FC-C545-4D46-8FB0-786C11002C2F}" dt="2025-03-31T16:32:27.690" v="2352" actId="1076"/>
+        <pc:sldMkLst>
+          <pc:docMk/>
+          <pc:sldMk cId="1368633886" sldId="274"/>
+        </pc:sldMkLst>
+        <pc:spChg chg="mod">
+          <ac:chgData name="Christian -" userId="c9558d0526991bde" providerId="LiveId" clId="{BB1FF1FC-C545-4D46-8FB0-786C11002C2F}" dt="2025-03-31T16:32:27.690" v="2352" actId="1076"/>
+          <ac:spMkLst>
+            <pc:docMk/>
+            <pc:sldMk cId="1368633886" sldId="274"/>
+            <ac:spMk id="3" creationId="{B7137BAD-0618-E5FE-69CC-4F7921D1488F}"/>
+          </ac:spMkLst>
+        </pc:spChg>
+        <pc:spChg chg="add mod">
+          <ac:chgData name="Christian -" userId="c9558d0526991bde" providerId="LiveId" clId="{BB1FF1FC-C545-4D46-8FB0-786C11002C2F}" dt="2025-03-31T16:32:15.406" v="2346" actId="1076"/>
+          <ac:spMkLst>
+            <pc:docMk/>
+            <pc:sldMk cId="1368633886" sldId="274"/>
+            <ac:spMk id="6" creationId="{EBE80821-8307-69F7-0437-4A709E25DBF9}"/>
+          </ac:spMkLst>
+        </pc:spChg>
+        <pc:spChg chg="add mod">
+          <ac:chgData name="Christian -" userId="c9558d0526991bde" providerId="LiveId" clId="{BB1FF1FC-C545-4D46-8FB0-786C11002C2F}" dt="2025-03-31T16:32:15.406" v="2346" actId="1076"/>
+          <ac:spMkLst>
+            <pc:docMk/>
+            <pc:sldMk cId="1368633886" sldId="274"/>
+            <ac:spMk id="7" creationId="{19E61AB9-B630-6E63-BD59-D616D112D7EC}"/>
+          </ac:spMkLst>
+        </pc:spChg>
+        <pc:spChg chg="add mod">
+          <ac:chgData name="Christian -" userId="c9558d0526991bde" providerId="LiveId" clId="{BB1FF1FC-C545-4D46-8FB0-786C11002C2F}" dt="2025-03-31T16:32:15.406" v="2346" actId="1076"/>
+          <ac:spMkLst>
+            <pc:docMk/>
+            <pc:sldMk cId="1368633886" sldId="274"/>
+            <ac:spMk id="8" creationId="{F963D624-228B-89BF-4197-6F74762C14DD}"/>
+          </ac:spMkLst>
+        </pc:spChg>
+        <pc:spChg chg="add mod">
+          <ac:chgData name="Christian -" userId="c9558d0526991bde" providerId="LiveId" clId="{BB1FF1FC-C545-4D46-8FB0-786C11002C2F}" dt="2025-03-31T16:32:15.406" v="2346" actId="1076"/>
+          <ac:spMkLst>
+            <pc:docMk/>
+            <pc:sldMk cId="1368633886" sldId="274"/>
+            <ac:spMk id="10" creationId="{E6DFD9FF-4F2C-77D3-96A9-978437627BA0}"/>
+          </ac:spMkLst>
+        </pc:spChg>
+        <pc:spChg chg="add mod">
+          <ac:chgData name="Christian -" userId="c9558d0526991bde" providerId="LiveId" clId="{BB1FF1FC-C545-4D46-8FB0-786C11002C2F}" dt="2025-03-31T16:32:15.406" v="2346" actId="1076"/>
+          <ac:spMkLst>
+            <pc:docMk/>
+            <pc:sldMk cId="1368633886" sldId="274"/>
+            <ac:spMk id="11" creationId="{09FB12B8-C213-8388-E2B2-0B4FB5C55E4E}"/>
+          </ac:spMkLst>
+        </pc:spChg>
+        <pc:spChg chg="add mod">
+          <ac:chgData name="Christian -" userId="c9558d0526991bde" providerId="LiveId" clId="{BB1FF1FC-C545-4D46-8FB0-786C11002C2F}" dt="2025-03-31T16:32:15.406" v="2346" actId="1076"/>
+          <ac:spMkLst>
+            <pc:docMk/>
+            <pc:sldMk cId="1368633886" sldId="274"/>
+            <ac:spMk id="12" creationId="{60BB14F0-B33C-CA05-FAEF-537075746A4B}"/>
+          </ac:spMkLst>
+        </pc:spChg>
+        <pc:spChg chg="add mod">
+          <ac:chgData name="Christian -" userId="c9558d0526991bde" providerId="LiveId" clId="{BB1FF1FC-C545-4D46-8FB0-786C11002C2F}" dt="2025-03-31T16:32:15.406" v="2346" actId="1076"/>
+          <ac:spMkLst>
+            <pc:docMk/>
+            <pc:sldMk cId="1368633886" sldId="274"/>
+            <ac:spMk id="13" creationId="{64069CFF-B8F4-4930-C895-A7970A41564E}"/>
+          </ac:spMkLst>
+        </pc:spChg>
+        <pc:spChg chg="add mod">
+          <ac:chgData name="Christian -" userId="c9558d0526991bde" providerId="LiveId" clId="{BB1FF1FC-C545-4D46-8FB0-786C11002C2F}" dt="2025-03-31T16:32:15.406" v="2346" actId="1076"/>
+          <ac:spMkLst>
+            <pc:docMk/>
+            <pc:sldMk cId="1368633886" sldId="274"/>
+            <ac:spMk id="14" creationId="{93A5B015-D2CC-8AA2-A11E-2667153A0ABB}"/>
+          </ac:spMkLst>
+        </pc:spChg>
+        <pc:picChg chg="add mod">
+          <ac:chgData name="Christian -" userId="c9558d0526991bde" providerId="LiveId" clId="{BB1FF1FC-C545-4D46-8FB0-786C11002C2F}" dt="2025-03-31T16:32:15.406" v="2346" actId="1076"/>
+          <ac:picMkLst>
+            <pc:docMk/>
+            <pc:sldMk cId="1368633886" sldId="274"/>
+            <ac:picMk id="4" creationId="{AB348A50-EDF3-3964-3A1E-93D986AEE0CC}"/>
+          </ac:picMkLst>
+        </pc:picChg>
+        <pc:picChg chg="add mod">
+          <ac:chgData name="Christian -" userId="c9558d0526991bde" providerId="LiveId" clId="{BB1FF1FC-C545-4D46-8FB0-786C11002C2F}" dt="2025-03-18T14:29:13.078" v="2092" actId="1076"/>
+          <ac:picMkLst>
+            <pc:docMk/>
+            <pc:sldMk cId="1368633886" sldId="274"/>
+            <ac:picMk id="5" creationId="{0F24ABAF-9C08-7442-C5CA-C5EFA1D0EEC0}"/>
+          </ac:picMkLst>
+        </pc:picChg>
+        <pc:picChg chg="add mod">
+          <ac:chgData name="Christian -" userId="c9558d0526991bde" providerId="LiveId" clId="{BB1FF1FC-C545-4D46-8FB0-786C11002C2F}" dt="2025-03-31T16:32:15.406" v="2346" actId="1076"/>
+          <ac:picMkLst>
+            <pc:docMk/>
+            <pc:sldMk cId="1368633886" sldId="274"/>
+            <ac:picMk id="9" creationId="{A4A673B6-22A0-5152-BB78-F65E5DA14234}"/>
+          </ac:picMkLst>
+        </pc:picChg>
+      </pc:sldChg>
+    </pc:docChg>
+  </pc:docChgLst>
+  <pc:docChgLst>
+    <pc:chgData name="Christian -" userId="c9558d0526991bde" providerId="LiveId" clId="{EFD41045-05F8-413E-B1DE-4AF5018B6579}"/>
+    <pc:docChg chg="custSel addSld modSld sldOrd">
+      <pc:chgData name="Christian -" userId="c9558d0526991bde" providerId="LiveId" clId="{EFD41045-05F8-413E-B1DE-4AF5018B6579}" dt="2025-02-24T07:47:36.167" v="1192" actId="20577"/>
+      <pc:docMkLst>
+        <pc:docMk/>
+      </pc:docMkLst>
+      <pc:sldChg chg="modSp new mod">
+        <pc:chgData name="Christian -" userId="c9558d0526991bde" providerId="LiveId" clId="{EFD41045-05F8-413E-B1DE-4AF5018B6579}" dt="2025-02-23T18:39:54.538" v="386" actId="20577"/>
+        <pc:sldMkLst>
+          <pc:docMk/>
+          <pc:sldMk cId="1580336922" sldId="271"/>
+        </pc:sldMkLst>
+      </pc:sldChg>
+      <pc:sldChg chg="addSp modSp new mod">
+        <pc:chgData name="Christian -" userId="c9558d0526991bde" providerId="LiveId" clId="{EFD41045-05F8-413E-B1DE-4AF5018B6579}" dt="2025-02-23T18:53:13.776" v="1147" actId="20577"/>
+        <pc:sldMkLst>
+          <pc:docMk/>
+          <pc:sldMk cId="1566502231" sldId="272"/>
+        </pc:sldMkLst>
+      </pc:sldChg>
+      <pc:sldChg chg="modSp new mod">
+        <pc:chgData name="Christian -" userId="c9558d0526991bde" providerId="LiveId" clId="{EFD41045-05F8-413E-B1DE-4AF5018B6579}" dt="2025-02-24T07:47:16.295" v="1165" actId="20577"/>
+        <pc:sldMkLst>
+          <pc:docMk/>
+          <pc:sldMk cId="2923521188" sldId="273"/>
+        </pc:sldMkLst>
+      </pc:sldChg>
+      <pc:sldChg chg="modSp new mod ord">
+        <pc:chgData name="Christian -" userId="c9558d0526991bde" providerId="LiveId" clId="{EFD41045-05F8-413E-B1DE-4AF5018B6579}" dt="2025-02-24T07:47:36.167" v="1192" actId="20577"/>
+        <pc:sldMkLst>
+          <pc:docMk/>
+          <pc:sldMk cId="1368633886" sldId="274"/>
+        </pc:sldMkLst>
+        <pc:spChg chg="mod">
+          <ac:chgData name="Christian -" userId="c9558d0526991bde" providerId="LiveId" clId="{EFD41045-05F8-413E-B1DE-4AF5018B6579}" dt="2025-02-24T07:47:36.167" v="1192" actId="20577"/>
+          <ac:spMkLst>
+            <pc:docMk/>
+            <pc:sldMk cId="1368633886" sldId="274"/>
+            <ac:spMk id="2" creationId="{19EACA2C-4245-8E19-6AF1-CC3224A68987}"/>
+          </ac:spMkLst>
+        </pc:spChg>
+      </pc:sldChg>
+    </pc:docChg>
+  </pc:docChgLst>
   <pc:docChgLst>
     <pc:chgData name="Christian -" userId="c9558d0526991bde" providerId="LiveId" clId="{774FEED2-3CC2-4F88-81AF-7575B46E195E}"/>
     <pc:docChg chg="undo custSel addSld delSld modSld">
@@ -198,14 +685,6 @@
           <pc:docMk/>
           <pc:sldMk cId="2641459554" sldId="258"/>
         </pc:sldMkLst>
-        <pc:spChg chg="del mod">
-          <ac:chgData name="Christian -" userId="c9558d0526991bde" providerId="LiveId" clId="{774FEED2-3CC2-4F88-81AF-7575B46E195E}" dt="2025-01-23T16:22:55.525" v="3895" actId="478"/>
-          <ac:spMkLst>
-            <pc:docMk/>
-            <pc:sldMk cId="2641459554" sldId="258"/>
-            <ac:spMk id="4" creationId="{43AAF30D-BFA5-FA32-AD1C-4B2560A99AD0}"/>
-          </ac:spMkLst>
-        </pc:spChg>
         <pc:spChg chg="mod">
           <ac:chgData name="Christian -" userId="c9558d0526991bde" providerId="LiveId" clId="{774FEED2-3CC2-4F88-81AF-7575B46E195E}" dt="2025-01-23T16:32:42.315" v="4450" actId="20577"/>
           <ac:spMkLst>
@@ -222,22 +701,6 @@
             <ac:spMk id="8" creationId="{3FA879C3-4732-5FB6-637C-1DB83B0C071D}"/>
           </ac:spMkLst>
         </pc:spChg>
-        <pc:spChg chg="del">
-          <ac:chgData name="Christian -" userId="c9558d0526991bde" providerId="LiveId" clId="{774FEED2-3CC2-4F88-81AF-7575B46E195E}" dt="2025-01-23T16:22:56.253" v="3896" actId="478"/>
-          <ac:spMkLst>
-            <pc:docMk/>
-            <pc:sldMk cId="2641459554" sldId="258"/>
-            <ac:spMk id="10" creationId="{568C0718-0F93-F741-3E98-74DCACA334B1}"/>
-          </ac:spMkLst>
-        </pc:spChg>
-        <pc:spChg chg="del">
-          <ac:chgData name="Christian -" userId="c9558d0526991bde" providerId="LiveId" clId="{774FEED2-3CC2-4F88-81AF-7575B46E195E}" dt="2025-01-23T16:22:58.398" v="3898" actId="478"/>
-          <ac:spMkLst>
-            <pc:docMk/>
-            <pc:sldMk cId="2641459554" sldId="258"/>
-            <ac:spMk id="11" creationId="{3E3C82D8-4D8B-25E1-0644-96A9F51069C8}"/>
-          </ac:spMkLst>
-        </pc:spChg>
         <pc:spChg chg="add mod">
           <ac:chgData name="Christian -" userId="c9558d0526991bde" providerId="LiveId" clId="{774FEED2-3CC2-4F88-81AF-7575B46E195E}" dt="2025-01-23T16:26:47.601" v="4029" actId="1076"/>
           <ac:spMkLst>
@@ -252,22 +715,6 @@
             <pc:docMk/>
             <pc:sldMk cId="2641459554" sldId="258"/>
             <ac:picMk id="5" creationId="{FE14CB72-FF11-5EF5-2D4E-59C0E22E4F4C}"/>
-          </ac:picMkLst>
-        </pc:picChg>
-        <pc:picChg chg="del">
-          <ac:chgData name="Christian -" userId="c9558d0526991bde" providerId="LiveId" clId="{774FEED2-3CC2-4F88-81AF-7575B46E195E}" dt="2025-01-23T16:22:53.676" v="3893" actId="478"/>
-          <ac:picMkLst>
-            <pc:docMk/>
-            <pc:sldMk cId="2641459554" sldId="258"/>
-            <ac:picMk id="6" creationId="{643F0A30-F781-0321-ACD5-25942FEDB085}"/>
-          </ac:picMkLst>
-        </pc:picChg>
-        <pc:picChg chg="del">
-          <ac:chgData name="Christian -" userId="c9558d0526991bde" providerId="LiveId" clId="{774FEED2-3CC2-4F88-81AF-7575B46E195E}" dt="2025-01-23T16:22:56.980" v="3897" actId="478"/>
-          <ac:picMkLst>
-            <pc:docMk/>
-            <pc:sldMk cId="2641459554" sldId="258"/>
-            <ac:picMk id="9" creationId="{DA4C682C-3E47-ED89-1F30-1E9C351BDB15}"/>
           </ac:picMkLst>
         </pc:picChg>
         <pc:picChg chg="add mod">
@@ -316,22 +763,6 @@
             <ac:spMk id="4" creationId="{603813BB-9489-D2AC-9CF0-45218CAF28BC}"/>
           </ac:spMkLst>
         </pc:spChg>
-        <pc:spChg chg="mod">
-          <ac:chgData name="Christian -" userId="c9558d0526991bde" providerId="LiveId" clId="{774FEED2-3CC2-4F88-81AF-7575B46E195E}" dt="2025-01-23T16:46:49.685" v="4753" actId="1076"/>
-          <ac:spMkLst>
-            <pc:docMk/>
-            <pc:sldMk cId="4086018805" sldId="260"/>
-            <ac:spMk id="5" creationId="{AA4C2C93-477C-90D8-CA15-397843409DD0}"/>
-          </ac:spMkLst>
-        </pc:spChg>
-        <pc:picChg chg="mod">
-          <ac:chgData name="Christian -" userId="c9558d0526991bde" providerId="LiveId" clId="{774FEED2-3CC2-4F88-81AF-7575B46E195E}" dt="2025-01-23T16:46:53.251" v="4755" actId="1076"/>
-          <ac:picMkLst>
-            <pc:docMk/>
-            <pc:sldMk cId="4086018805" sldId="260"/>
-            <ac:picMk id="1026" creationId="{DD9F9587-0531-501E-95A9-CFDA089CBD75}"/>
-          </ac:picMkLst>
-        </pc:picChg>
       </pc:sldChg>
       <pc:sldChg chg="addSp delSp modSp mod">
         <pc:chgData name="Christian -" userId="c9558d0526991bde" providerId="LiveId" clId="{774FEED2-3CC2-4F88-81AF-7575B46E195E}" dt="2025-01-23T17:03:52.944" v="5302" actId="1076"/>
@@ -339,22 +770,6 @@
           <pc:docMk/>
           <pc:sldMk cId="352367978" sldId="261"/>
         </pc:sldMkLst>
-        <pc:spChg chg="mod">
-          <ac:chgData name="Christian -" userId="c9558d0526991bde" providerId="LiveId" clId="{774FEED2-3CC2-4F88-81AF-7575B46E195E}" dt="2025-01-23T17:03:37.654" v="5297" actId="1076"/>
-          <ac:spMkLst>
-            <pc:docMk/>
-            <pc:sldMk cId="352367978" sldId="261"/>
-            <ac:spMk id="3" creationId="{7D8CDBEA-48CD-65F8-C43A-582FB26C3B8B}"/>
-          </ac:spMkLst>
-        </pc:spChg>
-        <pc:spChg chg="add del mod">
-          <ac:chgData name="Christian -" userId="c9558d0526991bde" providerId="LiveId" clId="{774FEED2-3CC2-4F88-81AF-7575B46E195E}" dt="2025-01-23T15:03:21.662" v="844"/>
-          <ac:spMkLst>
-            <pc:docMk/>
-            <pc:sldMk cId="352367978" sldId="261"/>
-            <ac:spMk id="6" creationId="{103CE4EF-A71C-0E45-1F6C-86A16010F78E}"/>
-          </ac:spMkLst>
-        </pc:spChg>
         <pc:spChg chg="mod">
           <ac:chgData name="Christian -" userId="c9558d0526991bde" providerId="LiveId" clId="{774FEED2-3CC2-4F88-81AF-7575B46E195E}" dt="2025-01-23T17:03:14.512" v="5271" actId="122"/>
           <ac:spMkLst>
@@ -387,30 +802,6 @@
             <ac:spMk id="16" creationId="{5347D89C-F77F-72EB-D5CF-2A35CD7652FD}"/>
           </ac:spMkLst>
         </pc:spChg>
-        <pc:picChg chg="del">
-          <ac:chgData name="Christian -" userId="c9558d0526991bde" providerId="LiveId" clId="{774FEED2-3CC2-4F88-81AF-7575B46E195E}" dt="2025-01-23T15:03:13.818" v="842" actId="478"/>
-          <ac:picMkLst>
-            <pc:docMk/>
-            <pc:sldMk cId="352367978" sldId="261"/>
-            <ac:picMk id="5" creationId="{1204F82D-033D-989B-4214-B42312A7D799}"/>
-          </ac:picMkLst>
-        </pc:picChg>
-        <pc:picChg chg="del">
-          <ac:chgData name="Christian -" userId="c9558d0526991bde" providerId="LiveId" clId="{774FEED2-3CC2-4F88-81AF-7575B46E195E}" dt="2025-01-23T15:03:15.522" v="843" actId="478"/>
-          <ac:picMkLst>
-            <pc:docMk/>
-            <pc:sldMk cId="352367978" sldId="261"/>
-            <ac:picMk id="7" creationId="{FCEBEAD9-8BE3-DB01-A94C-B009B5631582}"/>
-          </ac:picMkLst>
-        </pc:picChg>
-        <pc:picChg chg="del">
-          <ac:chgData name="Christian -" userId="c9558d0526991bde" providerId="LiveId" clId="{774FEED2-3CC2-4F88-81AF-7575B46E195E}" dt="2025-01-23T15:03:11.325" v="841" actId="478"/>
-          <ac:picMkLst>
-            <pc:docMk/>
-            <pc:sldMk cId="352367978" sldId="261"/>
-            <ac:picMk id="12" creationId="{10B4A7BF-7404-B892-F302-47C24B4C88CC}"/>
-          </ac:picMkLst>
-        </pc:picChg>
         <pc:picChg chg="add mod">
           <ac:chgData name="Christian -" userId="c9558d0526991bde" providerId="LiveId" clId="{774FEED2-3CC2-4F88-81AF-7575B46E195E}" dt="2025-01-23T16:47:37.479" v="4761" actId="1076"/>
           <ac:picMkLst>
@@ -425,14 +816,6 @@
             <pc:docMk/>
             <pc:sldMk cId="352367978" sldId="261"/>
             <ac:picMk id="15" creationId="{E5E1A133-5CB2-7867-650C-2DDE0C0535CA}"/>
-          </ac:picMkLst>
-        </pc:picChg>
-        <pc:picChg chg="add mod">
-          <ac:chgData name="Christian -" userId="c9558d0526991bde" providerId="LiveId" clId="{774FEED2-3CC2-4F88-81AF-7575B46E195E}" dt="2025-01-23T17:03:48.812" v="5301" actId="1076"/>
-          <ac:picMkLst>
-            <pc:docMk/>
-            <pc:sldMk cId="352367978" sldId="261"/>
-            <ac:picMk id="18" creationId="{3D586A4B-ADAC-2A41-6BBF-F02F84C9D67D}"/>
           </ac:picMkLst>
         </pc:picChg>
       </pc:sldChg>
@@ -458,14 +841,6 @@
             <ac:spMk id="7" creationId="{E6A18AAC-BF72-B3F3-BB41-9690FE61C885}"/>
           </ac:spMkLst>
         </pc:spChg>
-        <pc:picChg chg="del">
-          <ac:chgData name="Christian -" userId="c9558d0526991bde" providerId="LiveId" clId="{774FEED2-3CC2-4F88-81AF-7575B46E195E}" dt="2025-01-23T15:15:17.508" v="1017" actId="478"/>
-          <ac:picMkLst>
-            <pc:docMk/>
-            <pc:sldMk cId="157072469" sldId="263"/>
-            <ac:picMk id="5" creationId="{7C71EBEE-C56D-D63A-6B79-5B8F7E906A73}"/>
-          </ac:picMkLst>
-        </pc:picChg>
         <pc:picChg chg="add mod">
           <ac:chgData name="Christian -" userId="c9558d0526991bde" providerId="LiveId" clId="{774FEED2-3CC2-4F88-81AF-7575B46E195E}" dt="2025-01-23T15:40:56.033" v="2263" actId="1076"/>
           <ac:picMkLst>
@@ -838,30 +1213,6 @@
           </ac:spMkLst>
         </pc:spChg>
         <pc:spChg chg="add mod">
-          <ac:chgData name="Christian -" userId="c9558d0526991bde" providerId="LiveId" clId="{774FEED2-3CC2-4F88-81AF-7575B46E195E}" dt="2025-01-23T16:12:24.451" v="3585"/>
-          <ac:spMkLst>
-            <pc:docMk/>
-            <pc:sldMk cId="2247630597" sldId="268"/>
-            <ac:spMk id="4" creationId="{A8509CF7-C998-4053-4D47-B54B54EFC836}"/>
-          </ac:spMkLst>
-        </pc:spChg>
-        <pc:spChg chg="add mod">
-          <ac:chgData name="Christian -" userId="c9558d0526991bde" providerId="LiveId" clId="{774FEED2-3CC2-4F88-81AF-7575B46E195E}" dt="2025-01-23T16:12:24.451" v="3585"/>
-          <ac:spMkLst>
-            <pc:docMk/>
-            <pc:sldMk cId="2247630597" sldId="268"/>
-            <ac:spMk id="5" creationId="{E2A26085-2BC2-A31A-C6C5-A544C71AB2B5}"/>
-          </ac:spMkLst>
-        </pc:spChg>
-        <pc:spChg chg="del">
-          <ac:chgData name="Christian -" userId="c9558d0526991bde" providerId="LiveId" clId="{774FEED2-3CC2-4F88-81AF-7575B46E195E}" dt="2025-01-23T16:15:19.158" v="3659" actId="478"/>
-          <ac:spMkLst>
-            <pc:docMk/>
-            <pc:sldMk cId="2247630597" sldId="268"/>
-            <ac:spMk id="14" creationId="{4BC5310D-36A4-575D-F2FE-5108351F85C9}"/>
-          </ac:spMkLst>
-        </pc:spChg>
-        <pc:spChg chg="add mod">
           <ac:chgData name="Christian -" userId="c9558d0526991bde" providerId="LiveId" clId="{774FEED2-3CC2-4F88-81AF-7575B46E195E}" dt="2025-01-23T16:18:02.925" v="3811" actId="20577"/>
           <ac:spMkLst>
             <pc:docMk/>
@@ -885,14 +1236,6 @@
             <ac:spMk id="38" creationId="{385A4048-7D9E-A2C6-18B3-24B8ACC4EBF7}"/>
           </ac:spMkLst>
         </pc:spChg>
-        <pc:grpChg chg="add del mod">
-          <ac:chgData name="Christian -" userId="c9558d0526991bde" providerId="LiveId" clId="{774FEED2-3CC2-4F88-81AF-7575B46E195E}" dt="2025-01-23T16:12:28.577" v="3586" actId="478"/>
-          <ac:grpSpMkLst>
-            <pc:docMk/>
-            <pc:sldMk cId="2247630597" sldId="268"/>
-            <ac:grpSpMk id="3" creationId="{E30B15D2-39C4-7D6F-08A4-0B7C5CCB32A9}"/>
-          </ac:grpSpMkLst>
-        </pc:grpChg>
         <pc:graphicFrameChg chg="add mod">
           <ac:chgData name="Christian -" userId="c9558d0526991bde" providerId="LiveId" clId="{774FEED2-3CC2-4F88-81AF-7575B46E195E}" dt="2025-01-23T16:15:22.811" v="3660" actId="1076"/>
           <ac:graphicFrameMkLst>
@@ -901,36 +1244,12 @@
             <ac:graphicFrameMk id="6" creationId="{2037E7E6-6EE5-8A78-36B1-990DAA126EA8}"/>
           </ac:graphicFrameMkLst>
         </pc:graphicFrameChg>
-        <pc:graphicFrameChg chg="del mod">
-          <ac:chgData name="Christian -" userId="c9558d0526991bde" providerId="LiveId" clId="{774FEED2-3CC2-4F88-81AF-7575B46E195E}" dt="2025-01-23T16:13:44.289" v="3627" actId="478"/>
-          <ac:graphicFrameMkLst>
-            <pc:docMk/>
-            <pc:sldMk cId="2247630597" sldId="268"/>
-            <ac:graphicFrameMk id="10" creationId="{1A08D7A1-5014-D1FE-378F-78AFB2B498B2}"/>
-          </ac:graphicFrameMkLst>
-        </pc:graphicFrameChg>
-        <pc:graphicFrameChg chg="del mod">
-          <ac:chgData name="Christian -" userId="c9558d0526991bde" providerId="LiveId" clId="{774FEED2-3CC2-4F88-81AF-7575B46E195E}" dt="2025-01-23T16:14:41.280" v="3645" actId="478"/>
-          <ac:graphicFrameMkLst>
-            <pc:docMk/>
-            <pc:sldMk cId="2247630597" sldId="268"/>
-            <ac:graphicFrameMk id="11" creationId="{D87D65A0-C2C2-B22A-9BF9-C877939DEC0F}"/>
-          </ac:graphicFrameMkLst>
-        </pc:graphicFrameChg>
         <pc:graphicFrameChg chg="mod">
           <ac:chgData name="Christian -" userId="c9558d0526991bde" providerId="LiveId" clId="{774FEED2-3CC2-4F88-81AF-7575B46E195E}" dt="2025-01-23T16:14:49.179" v="3648" actId="1076"/>
           <ac:graphicFrameMkLst>
             <pc:docMk/>
             <pc:sldMk cId="2247630597" sldId="268"/>
             <ac:graphicFrameMk id="12" creationId="{4EEA16DA-B8D9-6372-50B0-29B936A2C4F0}"/>
-          </ac:graphicFrameMkLst>
-        </pc:graphicFrameChg>
-        <pc:graphicFrameChg chg="del">
-          <ac:chgData name="Christian -" userId="c9558d0526991bde" providerId="LiveId" clId="{774FEED2-3CC2-4F88-81AF-7575B46E195E}" dt="2025-01-23T16:14:35.471" v="3642" actId="478"/>
-          <ac:graphicFrameMkLst>
-            <pc:docMk/>
-            <pc:sldMk cId="2247630597" sldId="268"/>
-            <ac:graphicFrameMk id="13" creationId="{3DF6D169-787C-9AD6-D75A-E486D2807932}"/>
           </ac:graphicFrameMkLst>
         </pc:graphicFrameChg>
         <pc:graphicFrameChg chg="add mod">
@@ -1011,14 +1330,6 @@
             <pc:docMk/>
             <pc:sldMk cId="2247630597" sldId="268"/>
             <ac:cxnSpMk id="27" creationId="{69A7AD02-5F45-D64F-2E48-0D7598D8A631}"/>
-          </ac:cxnSpMkLst>
-        </pc:cxnChg>
-        <pc:cxnChg chg="del">
-          <ac:chgData name="Christian -" userId="c9558d0526991bde" providerId="LiveId" clId="{774FEED2-3CC2-4F88-81AF-7575B46E195E}" dt="2025-01-23T16:13:53.463" v="3630" actId="478"/>
-          <ac:cxnSpMkLst>
-            <pc:docMk/>
-            <pc:sldMk cId="2247630597" sldId="268"/>
-            <ac:cxnSpMk id="30" creationId="{D2193A51-68CA-A44E-2710-6267E798EA82}"/>
           </ac:cxnSpMkLst>
         </pc:cxnChg>
         <pc:cxnChg chg="add mod">
@@ -14511,7 +14822,7 @@
       <dgm:spPr/>
     </dgm:pt>
     <dgm:pt modelId="{C6B51FF5-75E3-476E-8196-1319A4D4BDC3}" type="pres">
-      <dgm:prSet presAssocID="{888BE427-EC92-4104-A268-F6FC0CA73C59}" presName="node" presStyleLbl="node1" presStyleIdx="1" presStyleCnt="2" custLinFactNeighborX="118" custLinFactNeighborY="0">
+      <dgm:prSet presAssocID="{888BE427-EC92-4104-A268-F6FC0CA73C59}" presName="node" presStyleLbl="node1" presStyleIdx="1" presStyleCnt="2" custLinFactNeighborX="-7216" custLinFactNeighborY="-1254">
         <dgm:presLayoutVars>
           <dgm:bulletEnabled val="1"/>
         </dgm:presLayoutVars>
@@ -14897,7 +15208,7 @@
         <a:p>
           <a:r>
             <a:rPr lang="da-DK" dirty="0" err="1"/>
-            <a:t>vtkAppend-PolyData</a:t>
+            <a:t>Actor</a:t>
           </a:r>
           <a:endParaRPr lang="da-DK" dirty="0"/>
         </a:p>
@@ -19681,9 +19992,9 @@
         <dsp:cNvSpPr/>
       </dsp:nvSpPr>
       <dsp:spPr>
-        <a:xfrm>
-          <a:off x="1001750" y="1039034"/>
-          <a:ext cx="193188" cy="225728"/>
+        <a:xfrm rot="21574062">
+          <a:off x="995073" y="1034288"/>
+          <a:ext cx="179042" cy="225728"/>
         </a:xfrm>
         <a:prstGeom prst="rightArrow">
           <a:avLst>
@@ -19741,8 +20052,8 @@
         </a:p>
       </dsp:txBody>
       <dsp:txXfrm>
-        <a:off x="1001750" y="1084180"/>
-        <a:ext cx="135232" cy="135436"/>
+        <a:off x="995074" y="1079637"/>
+        <a:ext cx="125329" cy="135436"/>
       </dsp:txXfrm>
     </dsp:sp>
     <dsp:sp modelId="{C6B51FF5-75E3-476E-8196-1319A4D4BDC3}">
@@ -19752,7 +20063,7 @@
       </dsp:nvSpPr>
       <dsp:spPr>
         <a:xfrm>
-          <a:off x="1275129" y="776442"/>
+          <a:off x="1248431" y="767026"/>
           <a:ext cx="910197" cy="750912"/>
         </a:xfrm>
         <a:prstGeom prst="roundRect">
@@ -19824,7 +20135,7 @@
         </a:p>
       </dsp:txBody>
       <dsp:txXfrm>
-        <a:off x="1297122" y="798435"/>
+        <a:off x="1270424" y="789019"/>
         <a:ext cx="866211" cy="706926"/>
       </dsp:txXfrm>
     </dsp:sp>
@@ -20281,7 +20592,7 @@
           </a:pPr>
           <a:r>
             <a:rPr lang="da-DK" sz="1100" kern="1200" dirty="0" err="1"/>
-            <a:t>vtkAppend-PolyData</a:t>
+            <a:t>Actor</a:t>
           </a:r>
           <a:endParaRPr lang="da-DK" sz="1100" kern="1200" dirty="0"/>
         </a:p>
@@ -37719,7 +38030,7 @@
           <a:p>
             <a:fld id="{56015244-B043-40BA-B4DF-5AD7BD069936}" type="datetimeFigureOut">
               <a:rPr lang="da-DK" smtClean="0"/>
-              <a:t>23-01-2025</a:t>
+              <a:t>31-03-2025</a:t>
             </a:fld>
             <a:endParaRPr lang="da-DK"/>
           </a:p>
@@ -38301,7 +38612,7 @@
           <a:p>
             <a:fld id="{5F12A875-1991-4229-9982-5387C6A95158}" type="datetimeFigureOut">
               <a:rPr lang="da-DK" smtClean="0"/>
-              <a:t>23-01-2025</a:t>
+              <a:t>31-03-2025</a:t>
             </a:fld>
             <a:endParaRPr lang="da-DK"/>
           </a:p>
@@ -38499,7 +38810,7 @@
           <a:p>
             <a:fld id="{5F12A875-1991-4229-9982-5387C6A95158}" type="datetimeFigureOut">
               <a:rPr lang="da-DK" smtClean="0"/>
-              <a:t>23-01-2025</a:t>
+              <a:t>31-03-2025</a:t>
             </a:fld>
             <a:endParaRPr lang="da-DK"/>
           </a:p>
@@ -38707,7 +39018,7 @@
           <a:p>
             <a:fld id="{5F12A875-1991-4229-9982-5387C6A95158}" type="datetimeFigureOut">
               <a:rPr lang="da-DK" smtClean="0"/>
-              <a:t>23-01-2025</a:t>
+              <a:t>31-03-2025</a:t>
             </a:fld>
             <a:endParaRPr lang="da-DK"/>
           </a:p>
@@ -38905,7 +39216,7 @@
           <a:p>
             <a:fld id="{5F12A875-1991-4229-9982-5387C6A95158}" type="datetimeFigureOut">
               <a:rPr lang="da-DK" smtClean="0"/>
-              <a:t>23-01-2025</a:t>
+              <a:t>31-03-2025</a:t>
             </a:fld>
             <a:endParaRPr lang="da-DK"/>
           </a:p>
@@ -39180,7 +39491,7 @@
           <a:p>
             <a:fld id="{5F12A875-1991-4229-9982-5387C6A95158}" type="datetimeFigureOut">
               <a:rPr lang="da-DK" smtClean="0"/>
-              <a:t>23-01-2025</a:t>
+              <a:t>31-03-2025</a:t>
             </a:fld>
             <a:endParaRPr lang="da-DK"/>
           </a:p>
@@ -39445,7 +39756,7 @@
           <a:p>
             <a:fld id="{5F12A875-1991-4229-9982-5387C6A95158}" type="datetimeFigureOut">
               <a:rPr lang="da-DK" smtClean="0"/>
-              <a:t>23-01-2025</a:t>
+              <a:t>31-03-2025</a:t>
             </a:fld>
             <a:endParaRPr lang="da-DK"/>
           </a:p>
@@ -39857,7 +40168,7 @@
           <a:p>
             <a:fld id="{5F12A875-1991-4229-9982-5387C6A95158}" type="datetimeFigureOut">
               <a:rPr lang="da-DK" smtClean="0"/>
-              <a:t>23-01-2025</a:t>
+              <a:t>31-03-2025</a:t>
             </a:fld>
             <a:endParaRPr lang="da-DK"/>
           </a:p>
@@ -39998,7 +40309,7 @@
           <a:p>
             <a:fld id="{5F12A875-1991-4229-9982-5387C6A95158}" type="datetimeFigureOut">
               <a:rPr lang="da-DK" smtClean="0"/>
-              <a:t>23-01-2025</a:t>
+              <a:t>31-03-2025</a:t>
             </a:fld>
             <a:endParaRPr lang="da-DK"/>
           </a:p>
@@ -40111,7 +40422,7 @@
           <a:p>
             <a:fld id="{5F12A875-1991-4229-9982-5387C6A95158}" type="datetimeFigureOut">
               <a:rPr lang="da-DK" smtClean="0"/>
-              <a:t>23-01-2025</a:t>
+              <a:t>31-03-2025</a:t>
             </a:fld>
             <a:endParaRPr lang="da-DK"/>
           </a:p>
@@ -40422,7 +40733,7 @@
           <a:p>
             <a:fld id="{5F12A875-1991-4229-9982-5387C6A95158}" type="datetimeFigureOut">
               <a:rPr lang="da-DK" smtClean="0"/>
-              <a:t>23-01-2025</a:t>
+              <a:t>31-03-2025</a:t>
             </a:fld>
             <a:endParaRPr lang="da-DK"/>
           </a:p>
@@ -40710,7 +41021,7 @@
           <a:p>
             <a:fld id="{5F12A875-1991-4229-9982-5387C6A95158}" type="datetimeFigureOut">
               <a:rPr lang="da-DK" smtClean="0"/>
-              <a:t>23-01-2025</a:t>
+              <a:t>31-03-2025</a:t>
             </a:fld>
             <a:endParaRPr lang="da-DK"/>
           </a:p>
@@ -40951,7 +41262,7 @@
           <a:p>
             <a:fld id="{5F12A875-1991-4229-9982-5387C6A95158}" type="datetimeFigureOut">
               <a:rPr lang="da-DK" smtClean="0"/>
-              <a:t>23-01-2025</a:t>
+              <a:t>31-03-2025</a:t>
             </a:fld>
             <a:endParaRPr lang="da-DK"/>
           </a:p>
@@ -41837,6 +42148,179 @@
           <p:cNvPr id="2" name="Titel 1">
             <a:extLst>
               <a:ext uri="{FF2B5EF4-FFF2-40B4-BE49-F238E27FC236}">
+                <a16:creationId xmlns:a16="http://schemas.microsoft.com/office/drawing/2014/main" id="{78779485-A8AA-95AF-2752-C5851A0111E5}"/>
+              </a:ext>
+            </a:extLst>
+          </p:cNvPr>
+          <p:cNvSpPr>
+            <a:spLocks noGrp="1"/>
+          </p:cNvSpPr>
+          <p:nvPr>
+            <p:ph type="ctrTitle"/>
+          </p:nvPr>
+        </p:nvSpPr>
+        <p:spPr/>
+        <p:txBody>
+          <a:bodyPr/>
+          <a:lstStyle/>
+          <a:p>
+            <a:r>
+              <a:rPr lang="da-DK" dirty="0"/>
+              <a:t>Part 2</a:t>
+            </a:r>
+          </a:p>
+        </p:txBody>
+      </p:sp>
+      <p:sp>
+        <p:nvSpPr>
+          <p:cNvPr id="3" name="Undertitel 2">
+            <a:extLst>
+              <a:ext uri="{FF2B5EF4-FFF2-40B4-BE49-F238E27FC236}">
+                <a16:creationId xmlns:a16="http://schemas.microsoft.com/office/drawing/2014/main" id="{FB6D1EAF-4116-2747-FEE8-2D964FC616C9}"/>
+              </a:ext>
+            </a:extLst>
+          </p:cNvPr>
+          <p:cNvSpPr>
+            <a:spLocks noGrp="1"/>
+          </p:cNvSpPr>
+          <p:nvPr>
+            <p:ph type="subTitle" idx="1"/>
+          </p:nvPr>
+        </p:nvSpPr>
+        <p:spPr/>
+        <p:txBody>
+          <a:bodyPr/>
+          <a:lstStyle/>
+          <a:p>
+            <a:r>
+              <a:rPr lang="da-DK" dirty="0" err="1"/>
+              <a:t>Mostly</a:t>
+            </a:r>
+            <a:r>
+              <a:rPr lang="da-DK" dirty="0"/>
+              <a:t> relevant to </a:t>
+            </a:r>
+            <a:r>
+              <a:rPr lang="da-DK" dirty="0" err="1"/>
+              <a:t>staff</a:t>
+            </a:r>
+            <a:r>
+              <a:rPr lang="da-DK" dirty="0"/>
+              <a:t>/</a:t>
+            </a:r>
+            <a:r>
+              <a:rPr lang="da-DK" dirty="0" err="1"/>
+              <a:t>contributors</a:t>
+            </a:r>
+            <a:endParaRPr lang="da-DK" dirty="0"/>
+          </a:p>
+          <a:p>
+            <a:r>
+              <a:rPr lang="da-DK" dirty="0"/>
+              <a:t>This part </a:t>
+            </a:r>
+            <a:r>
+              <a:rPr lang="da-DK" dirty="0" err="1"/>
+              <a:t>should</a:t>
+            </a:r>
+            <a:r>
+              <a:rPr lang="da-DK" dirty="0"/>
+              <a:t> </a:t>
+            </a:r>
+            <a:r>
+              <a:rPr lang="da-DK" dirty="0" err="1"/>
+              <a:t>be</a:t>
+            </a:r>
+            <a:r>
+              <a:rPr lang="da-DK" dirty="0"/>
+              <a:t> </a:t>
+            </a:r>
+            <a:r>
+              <a:rPr lang="da-DK" dirty="0" err="1"/>
+              <a:t>mostly</a:t>
+            </a:r>
+            <a:r>
+              <a:rPr lang="da-DK" dirty="0"/>
+              <a:t> irrelevant to </a:t>
+            </a:r>
+            <a:r>
+              <a:rPr lang="da-DK" dirty="0" err="1"/>
+              <a:t>competitors</a:t>
+            </a:r>
+            <a:r>
+              <a:rPr lang="da-DK" dirty="0"/>
+              <a:t> </a:t>
+            </a:r>
+            <a:r>
+              <a:rPr lang="da-DK" dirty="0" err="1"/>
+              <a:t>that</a:t>
+            </a:r>
+            <a:r>
+              <a:rPr lang="da-DK" dirty="0"/>
+              <a:t> </a:t>
+            </a:r>
+            <a:r>
+              <a:rPr lang="da-DK" dirty="0" err="1"/>
+              <a:t>don’t</a:t>
+            </a:r>
+            <a:r>
+              <a:rPr lang="da-DK" dirty="0"/>
+              <a:t> </a:t>
+            </a:r>
+            <a:r>
+              <a:rPr lang="da-DK" dirty="0" err="1"/>
+              <a:t>wish</a:t>
+            </a:r>
+            <a:r>
+              <a:rPr lang="da-DK" dirty="0"/>
+              <a:t> to </a:t>
+            </a:r>
+            <a:r>
+              <a:rPr lang="da-DK" dirty="0" err="1"/>
+              <a:t>contribute</a:t>
+            </a:r>
+            <a:r>
+              <a:rPr lang="da-DK" dirty="0"/>
+              <a:t> to the script.</a:t>
+            </a:r>
+          </a:p>
+        </p:txBody>
+      </p:sp>
+    </p:spTree>
+    <p:extLst>
+      <p:ext uri="{BB962C8B-B14F-4D97-AF65-F5344CB8AC3E}">
+        <p14:creationId xmlns:p14="http://schemas.microsoft.com/office/powerpoint/2010/main" val="2522301294"/>
+      </p:ext>
+    </p:extLst>
+  </p:cSld>
+  <p:clrMapOvr>
+    <a:masterClrMapping/>
+  </p:clrMapOvr>
+</p:sld>
+</file>
+
+<file path=ppt/slides/slide11.xml><?xml version="1.0" encoding="utf-8"?>
+<p:sld xmlns:a="http://schemas.openxmlformats.org/drawingml/2006/main" xmlns:r="http://schemas.openxmlformats.org/officeDocument/2006/relationships" xmlns:p="http://schemas.openxmlformats.org/presentationml/2006/main">
+  <p:cSld>
+    <p:spTree>
+      <p:nvGrpSpPr>
+        <p:cNvPr id="1" name=""/>
+        <p:cNvGrpSpPr/>
+        <p:nvPr/>
+      </p:nvGrpSpPr>
+      <p:grpSpPr>
+        <a:xfrm>
+          <a:off x="0" y="0"/>
+          <a:ext cx="0" cy="0"/>
+          <a:chOff x="0" y="0"/>
+          <a:chExt cx="0" cy="0"/>
+        </a:xfrm>
+      </p:grpSpPr>
+      <p:sp>
+        <p:nvSpPr>
+          <p:cNvPr id="2" name="Titel 1">
+            <a:extLst>
+              <a:ext uri="{FF2B5EF4-FFF2-40B4-BE49-F238E27FC236}">
                 <a16:creationId xmlns:a16="http://schemas.microsoft.com/office/drawing/2014/main" id="{DA75E37E-DA28-2F49-8F4E-5D353D95C552}"/>
               </a:ext>
             </a:extLst>
@@ -41928,7 +42412,15 @@
             </a:r>
             <a:r>
               <a:rPr lang="en-US" dirty="0"/>
-              <a:t>is important, this specifies which function is called.</a:t>
+              <a:t>is important, this specifies which </a:t>
+            </a:r>
+            <a:r>
+              <a:rPr lang="en-US" b="1" dirty="0"/>
+              <a:t>“rule-function” </a:t>
+            </a:r>
+            <a:r>
+              <a:rPr lang="en-US" dirty="0"/>
+              <a:t>is called.</a:t>
             </a:r>
           </a:p>
           <a:p>
@@ -41937,7 +42429,15 @@
           <a:p>
             <a:r>
               <a:rPr lang="en-US" dirty="0"/>
-              <a:t>All rules must return a string that is added to the report. </a:t>
+              <a:t>All rules must return a </a:t>
+            </a:r>
+            <a:r>
+              <a:rPr lang="en-US" b="1" i="1" dirty="0"/>
+              <a:t>string</a:t>
+            </a:r>
+            <a:r>
+              <a:rPr lang="en-US" dirty="0"/>
+              <a:t> that is added to the report. </a:t>
             </a:r>
           </a:p>
           <a:p>
@@ -41973,7 +42473,7 @@
         </p:blipFill>
         <p:spPr>
           <a:xfrm>
-            <a:off x="7070666" y="1461569"/>
+            <a:off x="7330970" y="913347"/>
             <a:ext cx="3552523" cy="3490740"/>
           </a:xfrm>
           <a:prstGeom prst="rect">
@@ -41995,7 +42495,7 @@
         </p:nvSpPr>
         <p:spPr>
           <a:xfrm>
-            <a:off x="6994826" y="1053313"/>
+            <a:off x="7175034" y="544015"/>
             <a:ext cx="3497881" cy="369332"/>
           </a:xfrm>
           <a:prstGeom prst="rect">
@@ -42044,12 +42544,63 @@
           </a:p>
         </p:txBody>
       </p:sp>
+      <p:sp>
+        <p:nvSpPr>
+          <p:cNvPr id="14" name="Tekstfelt 13">
+            <a:extLst>
+              <a:ext uri="{FF2B5EF4-FFF2-40B4-BE49-F238E27FC236}">
+                <a16:creationId xmlns:a16="http://schemas.microsoft.com/office/drawing/2014/main" id="{A2CF13DA-42BF-E4E8-1546-CE4D99CD3D18}"/>
+              </a:ext>
+            </a:extLst>
+          </p:cNvPr>
+          <p:cNvSpPr txBox="1"/>
+          <p:nvPr/>
+        </p:nvSpPr>
+        <p:spPr>
+          <a:xfrm>
+            <a:off x="7667560" y="4404087"/>
+            <a:ext cx="2705805" cy="369332"/>
+          </a:xfrm>
+          <a:prstGeom prst="rect">
+            <a:avLst/>
+          </a:prstGeom>
+          <a:noFill/>
+        </p:spPr>
+        <p:txBody>
+          <a:bodyPr wrap="none" rtlCol="0">
+            <a:spAutoFit/>
+          </a:bodyPr>
+          <a:lstStyle/>
+          <a:p>
+            <a:r>
+              <a:rPr lang="da-DK" dirty="0"/>
+              <a:t>From </a:t>
+            </a:r>
+            <a:r>
+              <a:rPr lang="da-DK" dirty="0" err="1"/>
+              <a:t>scrutineer</a:t>
+            </a:r>
+            <a:r>
+              <a:rPr lang="da-DK" dirty="0"/>
+              <a:t> </a:t>
+            </a:r>
+            <a:r>
+              <a:rPr lang="da-DK" dirty="0" err="1"/>
+              <a:t>function</a:t>
+            </a:r>
+            <a:r>
+              <a:rPr lang="da-DK" dirty="0"/>
+              <a:t>:</a:t>
+            </a:r>
+          </a:p>
+        </p:txBody>
+      </p:sp>
       <p:pic>
         <p:nvPicPr>
-          <p:cNvPr id="13" name="Billede 12">
+          <p:cNvPr id="4" name="Billede 3">
             <a:extLst>
               <a:ext uri="{FF2B5EF4-FFF2-40B4-BE49-F238E27FC236}">
-                <a16:creationId xmlns:a16="http://schemas.microsoft.com/office/drawing/2014/main" id="{B79E8409-79ED-3A7E-034F-67AEB824C6E0}"/>
+                <a16:creationId xmlns:a16="http://schemas.microsoft.com/office/drawing/2014/main" id="{807453E4-F433-D89C-983C-567CB6849CD5}"/>
               </a:ext>
             </a:extLst>
           </p:cNvPr>
@@ -42066,65 +42617,14 @@
         </p:blipFill>
         <p:spPr>
           <a:xfrm>
-            <a:off x="6892513" y="5322755"/>
-            <a:ext cx="4062925" cy="1451996"/>
+            <a:off x="7246673" y="4773419"/>
+            <a:ext cx="3721115" cy="1917343"/>
           </a:xfrm>
           <a:prstGeom prst="rect">
             <a:avLst/>
           </a:prstGeom>
         </p:spPr>
       </p:pic>
-      <p:sp>
-        <p:nvSpPr>
-          <p:cNvPr id="14" name="Tekstfelt 13">
-            <a:extLst>
-              <a:ext uri="{FF2B5EF4-FFF2-40B4-BE49-F238E27FC236}">
-                <a16:creationId xmlns:a16="http://schemas.microsoft.com/office/drawing/2014/main" id="{A2CF13DA-42BF-E4E8-1546-CE4D99CD3D18}"/>
-              </a:ext>
-            </a:extLst>
-          </p:cNvPr>
-          <p:cNvSpPr txBox="1"/>
-          <p:nvPr/>
-        </p:nvSpPr>
-        <p:spPr>
-          <a:xfrm>
-            <a:off x="7494024" y="4956435"/>
-            <a:ext cx="2705805" cy="369332"/>
-          </a:xfrm>
-          <a:prstGeom prst="rect">
-            <a:avLst/>
-          </a:prstGeom>
-          <a:noFill/>
-        </p:spPr>
-        <p:txBody>
-          <a:bodyPr wrap="none" rtlCol="0">
-            <a:spAutoFit/>
-          </a:bodyPr>
-          <a:lstStyle/>
-          <a:p>
-            <a:r>
-              <a:rPr lang="da-DK" dirty="0"/>
-              <a:t>From </a:t>
-            </a:r>
-            <a:r>
-              <a:rPr lang="da-DK" dirty="0" err="1"/>
-              <a:t>scrutineer</a:t>
-            </a:r>
-            <a:r>
-              <a:rPr lang="da-DK" dirty="0"/>
-              <a:t> </a:t>
-            </a:r>
-            <a:r>
-              <a:rPr lang="da-DK" dirty="0" err="1"/>
-              <a:t>function</a:t>
-            </a:r>
-            <a:r>
-              <a:rPr lang="da-DK" dirty="0"/>
-              <a:t>:</a:t>
-            </a:r>
-          </a:p>
-        </p:txBody>
-      </p:sp>
     </p:spTree>
     <p:extLst>
       <p:ext uri="{BB962C8B-B14F-4D97-AF65-F5344CB8AC3E}">
@@ -42138,7 +42638,7 @@
 </p:sld>
 </file>
 
-<file path=ppt/slides/slide11.xml><?xml version="1.0" encoding="utf-8"?>
+<file path=ppt/slides/slide12.xml><?xml version="1.0" encoding="utf-8"?>
 <p:sld xmlns:a="http://schemas.openxmlformats.org/drawingml/2006/main" xmlns:r="http://schemas.openxmlformats.org/officeDocument/2006/relationships" xmlns:p="http://schemas.openxmlformats.org/presentationml/2006/main">
   <p:cSld>
     <p:spTree>
@@ -42292,7 +42792,15 @@
             </a:r>
             <a:r>
               <a:rPr lang="da-DK" sz="2000" dirty="0"/>
-              <a:t>” etc. </a:t>
+              <a:t>” etc. See </a:t>
+            </a:r>
+            <a:r>
+              <a:rPr lang="da-DK" sz="2000" b="1" dirty="0"/>
+              <a:t>camera_funs.py </a:t>
+            </a:r>
+            <a:r>
+              <a:rPr lang="da-DK" sz="2000" dirty="0"/>
+              <a:t>for more info</a:t>
             </a:r>
           </a:p>
           <a:p>
@@ -42302,7 +42810,7 @@
             </a:r>
             <a:r>
               <a:rPr lang="da-DK" sz="2000" b="1" dirty="0"/>
-              <a:t> </a:t>
+              <a:t> is </a:t>
             </a:r>
             <a:r>
               <a:rPr lang="da-DK" sz="2000" dirty="0" err="1"/>
@@ -42332,7 +42840,7 @@
             </a:r>
             <a:r>
               <a:rPr lang="da-DK" sz="2000" b="1" dirty="0"/>
-              <a:t> </a:t>
+              <a:t> is </a:t>
             </a:r>
             <a:r>
               <a:rPr lang="da-DK" sz="2000" dirty="0" err="1"/>
@@ -42345,8 +42853,49 @@
           </a:p>
           <a:p>
             <a:r>
-              <a:rPr lang="da-DK" sz="2000" b="1" dirty="0"/>
-              <a:t>Mask</a:t>
+              <a:rPr lang="da-DK" sz="2000" dirty="0"/>
+              <a:t>Focus </a:t>
+            </a:r>
+            <a:r>
+              <a:rPr lang="da-DK" sz="2000" dirty="0" err="1"/>
+              <a:t>specifies</a:t>
+            </a:r>
+            <a:r>
+              <a:rPr lang="da-DK" sz="2000" dirty="0"/>
+              <a:t> the part to </a:t>
+            </a:r>
+            <a:r>
+              <a:rPr lang="da-DK" sz="2000" dirty="0" err="1"/>
+              <a:t>focus</a:t>
+            </a:r>
+            <a:r>
+              <a:rPr lang="da-DK" sz="2000" dirty="0"/>
+              <a:t> the camera on, </a:t>
+            </a:r>
+            <a:r>
+              <a:rPr lang="da-DK" sz="2000" dirty="0" err="1"/>
+              <a:t>here</a:t>
+            </a:r>
+            <a:r>
+              <a:rPr lang="da-DK" sz="2000" dirty="0"/>
+              <a:t> the given </a:t>
+            </a:r>
+            <a:r>
+              <a:rPr lang="da-DK" sz="2000" dirty="0" err="1"/>
+              <a:t>geometry</a:t>
+            </a:r>
+            <a:r>
+              <a:rPr lang="da-DK" sz="2000" dirty="0"/>
+              <a:t>.  </a:t>
+            </a:r>
+          </a:p>
+          <a:p>
+            <a:pPr marL="0" indent="0">
+              <a:buNone/>
+            </a:pPr>
+            <a:r>
+              <a:rPr lang="da-DK" sz="2000" dirty="0" err="1"/>
+              <a:t>Geometries</a:t>
             </a:r>
             <a:r>
               <a:rPr lang="da-DK" sz="2000" dirty="0"/>
@@ -42354,7 +42903,7 @@
             </a:r>
             <a:r>
               <a:rPr lang="da-DK" sz="2000" dirty="0" err="1"/>
-              <a:t>colored</a:t>
+              <a:t>can</a:t>
             </a:r>
             <a:r>
               <a:rPr lang="da-DK" sz="2000" dirty="0"/>
@@ -42362,59 +42911,113 @@
             </a:r>
             <a:r>
               <a:rPr lang="da-DK" sz="2000" dirty="0" err="1"/>
-              <a:t>black</a:t>
+              <a:t>be</a:t>
             </a:r>
             <a:r>
               <a:rPr lang="da-DK" sz="2000" dirty="0"/>
               <a:t> </a:t>
             </a:r>
-          </a:p>
-          <a:p>
+            <a:r>
+              <a:rPr lang="da-DK" sz="2000" b="1" dirty="0" err="1"/>
+              <a:t>combined</a:t>
+            </a:r>
             <a:r>
               <a:rPr lang="da-DK" sz="2000" dirty="0"/>
-              <a:t>Focus </a:t>
+              <a:t> by </a:t>
             </a:r>
             <a:r>
               <a:rPr lang="da-DK" sz="2000" dirty="0" err="1"/>
-              <a:t>specifies</a:t>
+              <a:t>supplying</a:t>
             </a:r>
             <a:r>
               <a:rPr lang="da-DK" sz="2000" dirty="0"/>
-              <a:t> the part to </a:t>
+              <a:t> a </a:t>
+            </a:r>
+            <a:r>
+              <a:rPr lang="da-DK" sz="2000" b="1" dirty="0"/>
+              <a:t>list of parts </a:t>
             </a:r>
             <a:r>
               <a:rPr lang="da-DK" sz="2000" dirty="0" err="1"/>
-              <a:t>focus</a:t>
+              <a:t>instead</a:t>
             </a:r>
             <a:r>
               <a:rPr lang="da-DK" sz="2000" dirty="0"/>
-              <a:t> the camera on, </a:t>
+              <a:t> of a </a:t>
             </a:r>
             <a:r>
               <a:rPr lang="da-DK" sz="2000" dirty="0" err="1"/>
-              <a:t>here</a:t>
+              <a:t>string</a:t>
             </a:r>
             <a:r>
               <a:rPr lang="da-DK" sz="2000" dirty="0"/>
-              <a:t> the given </a:t>
+              <a:t>. This </a:t>
             </a:r>
             <a:r>
               <a:rPr lang="da-DK" sz="2000" dirty="0" err="1"/>
-              <a:t>geometry</a:t>
+              <a:t>functionality</a:t>
             </a:r>
             <a:r>
               <a:rPr lang="da-DK" sz="2000" dirty="0"/>
-              <a:t>.   ½</a:t>
+              <a:t> </a:t>
+            </a:r>
+            <a:r>
+              <a:rPr lang="da-DK" sz="2000" dirty="0" err="1"/>
+              <a:t>replaces</a:t>
+            </a:r>
+            <a:r>
+              <a:rPr lang="da-DK" sz="2000" dirty="0"/>
+              <a:t> the ”masks” </a:t>
+            </a:r>
+            <a:r>
+              <a:rPr lang="da-DK" sz="2000" dirty="0" err="1"/>
+              <a:t>used</a:t>
+            </a:r>
+            <a:r>
+              <a:rPr lang="da-DK" sz="2000" dirty="0"/>
+              <a:t> in </a:t>
+            </a:r>
+            <a:r>
+              <a:rPr lang="da-DK" sz="2000" dirty="0" err="1"/>
+              <a:t>previous</a:t>
+            </a:r>
+            <a:r>
+              <a:rPr lang="da-DK" sz="2000" dirty="0"/>
+              <a:t> versions, </a:t>
+            </a:r>
+            <a:r>
+              <a:rPr lang="da-DK" sz="2000" dirty="0" err="1"/>
+              <a:t>because</a:t>
+            </a:r>
+            <a:r>
+              <a:rPr lang="da-DK" sz="2000" dirty="0"/>
+              <a:t> </a:t>
+            </a:r>
+            <a:r>
+              <a:rPr lang="da-DK" sz="2000" dirty="0" err="1"/>
+              <a:t>this</a:t>
+            </a:r>
+            <a:r>
+              <a:rPr lang="da-DK" sz="2000" dirty="0"/>
+              <a:t> is </a:t>
+            </a:r>
+            <a:r>
+              <a:rPr lang="da-DK" sz="2000" dirty="0" err="1"/>
+              <a:t>better</a:t>
+            </a:r>
+            <a:r>
+              <a:rPr lang="da-DK" sz="2000" dirty="0"/>
+              <a:t> </a:t>
             </a:r>
           </a:p>
         </p:txBody>
       </p:sp>
       <p:pic>
         <p:nvPicPr>
-          <p:cNvPr id="4" name="Billede 3">
+          <p:cNvPr id="6" name="Billede 5">
             <a:extLst>
               <a:ext uri="{FF2B5EF4-FFF2-40B4-BE49-F238E27FC236}">
-                <a16:creationId xmlns:a16="http://schemas.microsoft.com/office/drawing/2014/main" id="{047C3DF3-5F45-A187-4874-64EAD59CE924}"/>
+                <a16:creationId xmlns:a16="http://schemas.microsoft.com/office/drawing/2014/main" id="{A98E87B1-CDAC-BE4C-F23C-106B0FAEA59A}"/>
               </a:ext>
             </a:extLst>
           </p:cNvPr>
@@ -42431,8 +43034,38 @@
         </p:blipFill>
         <p:spPr>
           <a:xfrm>
-            <a:off x="8077024" y="4297795"/>
-            <a:ext cx="3852524" cy="2365410"/>
+            <a:off x="1388288" y="5332618"/>
+            <a:ext cx="5771664" cy="1345275"/>
+          </a:xfrm>
+          <a:prstGeom prst="rect">
+            <a:avLst/>
+          </a:prstGeom>
+        </p:spPr>
+      </p:pic>
+      <p:pic>
+        <p:nvPicPr>
+          <p:cNvPr id="8" name="Billede 7">
+            <a:extLst>
+              <a:ext uri="{FF2B5EF4-FFF2-40B4-BE49-F238E27FC236}">
+                <a16:creationId xmlns:a16="http://schemas.microsoft.com/office/drawing/2014/main" id="{C4A70F42-F75D-842C-7722-9BA7E08FBCD5}"/>
+              </a:ext>
+            </a:extLst>
+          </p:cNvPr>
+          <p:cNvPicPr>
+            <a:picLocks noChangeAspect="1"/>
+          </p:cNvPicPr>
+          <p:nvPr/>
+        </p:nvPicPr>
+        <p:blipFill>
+          <a:blip r:embed="rId3"/>
+          <a:stretch>
+            <a:fillRect/>
+          </a:stretch>
+        </p:blipFill>
+        <p:spPr>
+          <a:xfrm>
+            <a:off x="7535456" y="2735152"/>
+            <a:ext cx="4476333" cy="1633361"/>
           </a:xfrm>
           <a:prstGeom prst="rect">
             <a:avLst/>
@@ -42452,7 +43085,7 @@
 </p:sld>
 </file>
 
-<file path=ppt/slides/slide12.xml><?xml version="1.0" encoding="utf-8"?>
+<file path=ppt/slides/slide13.xml><?xml version="1.0" encoding="utf-8"?>
 <p:sld xmlns:a="http://schemas.openxmlformats.org/drawingml/2006/main" xmlns:r="http://schemas.openxmlformats.org/officeDocument/2006/relationships" xmlns:p="http://schemas.openxmlformats.org/presentationml/2006/main">
   <p:cSld>
     <p:spTree>
@@ -42502,6 +43135,14 @@
               <a:rPr lang="da-DK" dirty="0"/>
               <a:t> VTK-pipeline </a:t>
             </a:r>
+            <a:br>
+              <a:rPr lang="da-DK" dirty="0"/>
+            </a:br>
+            <a:r>
+              <a:rPr lang="da-DK" sz="2800" dirty="0"/>
+              <a:t>(for reference)</a:t>
+            </a:r>
+            <a:endParaRPr lang="da-DK" dirty="0"/>
           </a:p>
         </p:txBody>
       </p:sp>
@@ -42633,7 +43274,7 @@
 </p:sld>
 </file>
 
-<file path=ppt/slides/slide13.xml><?xml version="1.0" encoding="utf-8"?>
+<file path=ppt/slides/slide14.xml><?xml version="1.0" encoding="utf-8"?>
 <p:sld xmlns:a="http://schemas.openxmlformats.org/drawingml/2006/main" xmlns:r="http://schemas.openxmlformats.org/officeDocument/2006/relationships" xmlns:p="http://schemas.openxmlformats.org/presentationml/2006/main">
   <p:cSld>
     <p:spTree>
@@ -42978,13 +43619,13 @@
           <p:nvPr>
             <p:extLst>
               <p:ext uri="{D42A27DB-BD31-4B8C-83A1-F6EECF244321}">
-                <p14:modId xmlns:p14="http://schemas.microsoft.com/office/powerpoint/2010/main" val="4091628096"/>
+                <p14:modId xmlns:p14="http://schemas.microsoft.com/office/powerpoint/2010/main" val="129062450"/>
               </p:ext>
             </p:extLst>
           </p:nvPr>
         </p:nvGraphicFramePr>
         <p:xfrm>
-          <a:off x="5370153" y="1583478"/>
+          <a:off x="6737601" y="1436520"/>
           <a:ext cx="2185327" cy="2303798"/>
         </p:xfrm>
         <a:graphic>
@@ -43009,8 +43650,8 @@
         </p:nvCxnSpPr>
         <p:spPr>
           <a:xfrm flipV="1">
-            <a:off x="4870088" y="3111646"/>
-            <a:ext cx="500064" cy="628672"/>
+            <a:off x="7140672" y="3016853"/>
+            <a:ext cx="74411" cy="703639"/>
           </a:xfrm>
           <a:prstGeom prst="straightConnector1">
             <a:avLst/>
@@ -43050,8 +43691,8 @@
         </p:nvCxnSpPr>
         <p:spPr>
           <a:xfrm>
-            <a:off x="7578414" y="3111646"/>
-            <a:ext cx="503702" cy="613533"/>
+            <a:off x="8463206" y="3016853"/>
+            <a:ext cx="78611" cy="715895"/>
           </a:xfrm>
           <a:prstGeom prst="straightConnector1">
             <a:avLst/>
@@ -43119,6 +43760,90 @@
           </a:p>
         </p:txBody>
       </p:sp>
+      <p:sp>
+        <p:nvSpPr>
+          <p:cNvPr id="6" name="Tekstfelt 5">
+            <a:extLst>
+              <a:ext uri="{FF2B5EF4-FFF2-40B4-BE49-F238E27FC236}">
+                <a16:creationId xmlns:a16="http://schemas.microsoft.com/office/drawing/2014/main" id="{D5C57212-AAF0-07DD-DE0A-208079B394EE}"/>
+              </a:ext>
+            </a:extLst>
+          </p:cNvPr>
+          <p:cNvSpPr txBox="1"/>
+          <p:nvPr/>
+        </p:nvSpPr>
+        <p:spPr>
+          <a:xfrm>
+            <a:off x="6901384" y="5569545"/>
+            <a:ext cx="2669781" cy="1200329"/>
+          </a:xfrm>
+          <a:prstGeom prst="rect">
+            <a:avLst/>
+          </a:prstGeom>
+          <a:noFill/>
+        </p:spPr>
+        <p:txBody>
+          <a:bodyPr wrap="square" rtlCol="0">
+            <a:spAutoFit/>
+          </a:bodyPr>
+          <a:lstStyle/>
+          <a:p>
+            <a:r>
+              <a:rPr lang="da-DK" dirty="0" err="1"/>
+              <a:t>Bounding</a:t>
+            </a:r>
+            <a:r>
+              <a:rPr lang="da-DK" dirty="0"/>
+              <a:t> </a:t>
+            </a:r>
+            <a:r>
+              <a:rPr lang="da-DK" dirty="0" err="1"/>
+              <a:t>box</a:t>
+            </a:r>
+            <a:r>
+              <a:rPr lang="da-DK" dirty="0"/>
+              <a:t> </a:t>
+            </a:r>
+            <a:r>
+              <a:rPr lang="da-DK" dirty="0" err="1"/>
+              <a:t>coordinates</a:t>
+            </a:r>
+            <a:r>
+              <a:rPr lang="da-DK" dirty="0"/>
+              <a:t> </a:t>
+            </a:r>
+            <a:r>
+              <a:rPr lang="da-DK" dirty="0" err="1"/>
+              <a:t>are</a:t>
+            </a:r>
+            <a:r>
+              <a:rPr lang="da-DK" dirty="0"/>
+              <a:t> </a:t>
+            </a:r>
+            <a:r>
+              <a:rPr lang="da-DK" dirty="0" err="1"/>
+              <a:t>now</a:t>
+            </a:r>
+            <a:r>
+              <a:rPr lang="da-DK" dirty="0"/>
+              <a:t> (march 2025)  </a:t>
+            </a:r>
+            <a:r>
+              <a:rPr lang="da-DK" dirty="0" err="1"/>
+              <a:t>found</a:t>
+            </a:r>
+            <a:r>
+              <a:rPr lang="da-DK" dirty="0"/>
+              <a:t> from the </a:t>
+            </a:r>
+            <a:r>
+              <a:rPr lang="da-DK" dirty="0" err="1"/>
+              <a:t>actor</a:t>
+            </a:r>
+            <a:endParaRPr lang="da-DK" dirty="0"/>
+          </a:p>
+        </p:txBody>
+      </p:sp>
     </p:spTree>
     <p:extLst>
       <p:ext uri="{BB962C8B-B14F-4D97-AF65-F5344CB8AC3E}">
@@ -43132,7 +43857,7 @@
 </p:sld>
 </file>
 
-<file path=ppt/slides/slide14.xml><?xml version="1.0" encoding="utf-8"?>
+<file path=ppt/slides/slide15.xml><?xml version="1.0" encoding="utf-8"?>
 <p:sld xmlns:a="http://schemas.openxmlformats.org/drawingml/2006/main" xmlns:r="http://schemas.openxmlformats.org/officeDocument/2006/relationships" xmlns:p="http://schemas.openxmlformats.org/presentationml/2006/main">
   <p:cSld>
     <p:spTree>
@@ -43183,6 +43908,30 @@
             <a:r>
               <a:rPr lang="da-DK" dirty="0" err="1"/>
               <a:t>sections</a:t>
+            </a:r>
+            <a:r>
+              <a:rPr lang="da-DK" dirty="0"/>
+              <a:t> </a:t>
+            </a:r>
+            <a:r>
+              <a:rPr lang="da-DK" dirty="0" err="1"/>
+              <a:t>rule</a:t>
+            </a:r>
+            <a:r>
+              <a:rPr lang="da-DK" dirty="0"/>
+              <a:t> and top/</a:t>
+            </a:r>
+            <a:r>
+              <a:rPr lang="da-DK" dirty="0" err="1"/>
+              <a:t>bottom</a:t>
+            </a:r>
+            <a:r>
+              <a:rPr lang="da-DK" dirty="0"/>
+              <a:t> </a:t>
+            </a:r>
+            <a:r>
+              <a:rPr lang="da-DK" dirty="0" err="1"/>
+              <a:t>visibility</a:t>
             </a:r>
             <a:r>
               <a:rPr lang="da-DK" dirty="0"/>
@@ -43364,7 +44113,7 @@
           <p:nvPr>
             <p:extLst>
               <p:ext uri="{D42A27DB-BD31-4B8C-83A1-F6EECF244321}">
-                <p14:modId xmlns:p14="http://schemas.microsoft.com/office/powerpoint/2010/main" val="2630077092"/>
+                <p14:modId xmlns:p14="http://schemas.microsoft.com/office/powerpoint/2010/main" val="1941811340"/>
               </p:ext>
             </p:extLst>
           </p:nvPr>
@@ -44767,8 +45516,8 @@
         </p:nvSpPr>
         <p:spPr>
           <a:xfrm>
-            <a:off x="8688508" y="2272082"/>
-            <a:ext cx="3378902" cy="4278094"/>
+            <a:off x="8707649" y="2151558"/>
+            <a:ext cx="3378902" cy="4031873"/>
           </a:xfrm>
           <a:prstGeom prst="rect">
             <a:avLst/>
@@ -44783,7 +45532,41 @@
           <a:p>
             <a:r>
               <a:rPr lang="en-US" sz="1600" dirty="0"/>
-              <a:t>In the new structure there is a folder for each ”part” referenced in the rules </a:t>
+              <a:t>In the new structure there is a folder for each ”part” referenced in the rules.</a:t>
+            </a:r>
+          </a:p>
+          <a:p>
+            <a:r>
+              <a:rPr lang="en-US" sz="1600" dirty="0"/>
+              <a:t>Each folder can contain multiple </a:t>
+            </a:r>
+            <a:r>
+              <a:rPr lang="en-US" sz="1600" dirty="0" err="1"/>
+              <a:t>stls</a:t>
+            </a:r>
+            <a:r>
+              <a:rPr lang="en-US" sz="1600" dirty="0"/>
+              <a:t>.</a:t>
+            </a:r>
+          </a:p>
+          <a:p>
+            <a:r>
+              <a:rPr lang="en-US" sz="1600" dirty="0"/>
+              <a:t>So, more folders but no ambiguity about which </a:t>
+            </a:r>
+            <a:r>
+              <a:rPr lang="en-US" sz="1600" dirty="0" err="1"/>
+              <a:t>stls</a:t>
+            </a:r>
+            <a:r>
+              <a:rPr lang="en-US" sz="1600" dirty="0"/>
+              <a:t> belong to which parts.</a:t>
+            </a:r>
+          </a:p>
+          <a:p>
+            <a:r>
+              <a:rPr lang="en-US" sz="1600" dirty="0"/>
+              <a:t>Full list of parts should be specified in the rules. </a:t>
             </a:r>
           </a:p>
           <a:p>
@@ -44791,68 +45574,85 @@
           </a:p>
           <a:p>
             <a:r>
-              <a:rPr lang="en-US" sz="1600" dirty="0"/>
-              <a:t>Each folder can contain multiple </a:t>
-            </a:r>
-            <a:r>
-              <a:rPr lang="en-US" sz="1600" dirty="0" err="1"/>
-              <a:t>stls</a:t>
-            </a:r>
-            <a:r>
-              <a:rPr lang="en-US" sz="1600" dirty="0"/>
-              <a:t>.</a:t>
+              <a:rPr lang="en-US" sz="1600" b="1" dirty="0"/>
+              <a:t>After scrutineering, the .</a:t>
+            </a:r>
+            <a:r>
+              <a:rPr lang="en-US" sz="1600" b="1" dirty="0" err="1"/>
+              <a:t>stl</a:t>
+            </a:r>
+            <a:r>
+              <a:rPr lang="en-US" sz="1600" b="1" dirty="0"/>
+              <a:t> files are copied to a new "</a:t>
+            </a:r>
+            <a:r>
+              <a:rPr lang="en-US" sz="1600" b="1" dirty="0" err="1"/>
+              <a:t>input_file</a:t>
+            </a:r>
+            <a:r>
+              <a:rPr lang="en-US" sz="1600" b="1" dirty="0"/>
+              <a:t>" folder following the "old structure," making the submission  "</a:t>
+            </a:r>
+            <a:r>
+              <a:rPr lang="en-US" sz="1600" b="1" dirty="0" err="1"/>
+              <a:t>MFlow</a:t>
+            </a:r>
+            <a:r>
+              <a:rPr lang="en-US" sz="1600" b="1" dirty="0"/>
+              <a:t> ready."</a:t>
             </a:r>
           </a:p>
+        </p:txBody>
+      </p:sp>
+      <p:sp>
+        <p:nvSpPr>
+          <p:cNvPr id="8" name="Rektangel 7">
+            <a:extLst>
+              <a:ext uri="{FF2B5EF4-FFF2-40B4-BE49-F238E27FC236}">
+                <a16:creationId xmlns:a16="http://schemas.microsoft.com/office/drawing/2014/main" id="{C8CE1F5D-2BBB-5A93-4178-A32A108373D3}"/>
+              </a:ext>
+            </a:extLst>
+          </p:cNvPr>
+          <p:cNvSpPr/>
+          <p:nvPr/>
+        </p:nvSpPr>
+        <p:spPr>
+          <a:xfrm>
+            <a:off x="8707649" y="4733271"/>
+            <a:ext cx="3378902" cy="1538748"/>
+          </a:xfrm>
+          <a:prstGeom prst="rect">
+            <a:avLst/>
+          </a:prstGeom>
+          <a:noFill/>
+          <a:ln>
+            <a:solidFill>
+              <a:srgbClr val="FF0000"/>
+            </a:solidFill>
+          </a:ln>
+        </p:spPr>
+        <p:style>
+          <a:lnRef idx="2">
+            <a:schemeClr val="accent1">
+              <a:shade val="15000"/>
+            </a:schemeClr>
+          </a:lnRef>
+          <a:fillRef idx="1">
+            <a:schemeClr val="accent1"/>
+          </a:fillRef>
+          <a:effectRef idx="0">
+            <a:schemeClr val="accent1"/>
+          </a:effectRef>
+          <a:fontRef idx="minor">
+            <a:schemeClr val="lt1"/>
+          </a:fontRef>
+        </p:style>
+        <p:txBody>
+          <a:bodyPr rtlCol="0" anchor="ctr"/>
+          <a:lstStyle/>
           <a:p>
-            <a:endParaRPr lang="en-US" sz="1600" dirty="0"/>
-          </a:p>
-          <a:p>
-            <a:r>
-              <a:rPr lang="en-US" sz="1600" dirty="0"/>
-              <a:t>So, more folders but parts can easily be evaluated individually. </a:t>
-            </a:r>
-          </a:p>
-          <a:p>
-            <a:endParaRPr lang="en-US" sz="1600" dirty="0"/>
-          </a:p>
-          <a:p>
-            <a:r>
-              <a:rPr lang="en-US" sz="1600" dirty="0"/>
-              <a:t>Full list of parts should be specified in the rules. </a:t>
-            </a:r>
-          </a:p>
-          <a:p>
-            <a:endParaRPr lang="en-US" sz="1600" dirty="0"/>
-          </a:p>
-          <a:p>
-            <a:r>
-              <a:rPr lang="en-US" sz="1600" dirty="0"/>
-              <a:t>After scrutineering: </a:t>
-            </a:r>
-            <a:r>
-              <a:rPr lang="en-US" sz="1600" dirty="0" err="1"/>
-              <a:t>stls</a:t>
-            </a:r>
-            <a:r>
-              <a:rPr lang="en-US" sz="1600" dirty="0"/>
-              <a:t> are copied to a new “</a:t>
-            </a:r>
-            <a:r>
-              <a:rPr lang="en-US" sz="1600" dirty="0" err="1"/>
-              <a:t>input_file</a:t>
-            </a:r>
-            <a:r>
-              <a:rPr lang="en-US" sz="1600" dirty="0"/>
-              <a:t>” folder, following the “old structure”, thus making the submission “</a:t>
-            </a:r>
-            <a:r>
-              <a:rPr lang="en-US" sz="1600" dirty="0" err="1"/>
-              <a:t>MFlow</a:t>
-            </a:r>
-            <a:r>
-              <a:rPr lang="en-US" sz="1600" dirty="0"/>
-              <a:t> ready”.</a:t>
-            </a:r>
+            <a:pPr algn="ctr"/>
+            <a:endParaRPr lang="da-DK"/>
           </a:p>
         </p:txBody>
       </p:sp>
@@ -44951,13 +45751,25 @@
           <a:p>
             <a:r>
               <a:rPr lang="en-US" dirty="0"/>
-              <a:t>Obscure (hide, conceal etc.) </a:t>
+              <a:t>Obscure (read: to conceal etc.) </a:t>
             </a:r>
           </a:p>
           <a:p>
             <a:r>
               <a:rPr lang="en-US" dirty="0"/>
               <a:t>Number of sections </a:t>
+            </a:r>
+          </a:p>
+          <a:p>
+            <a:r>
+              <a:rPr lang="en-US" dirty="0"/>
+              <a:t>Top/bottom visibility </a:t>
+            </a:r>
+          </a:p>
+          <a:p>
+            <a:r>
+              <a:rPr lang="en-US" dirty="0"/>
+              <a:t>Bounding box size (not currently in use)</a:t>
             </a:r>
           </a:p>
           <a:p>
@@ -45157,7 +45969,7 @@
             </a:pPr>
             <a:r>
               <a:rPr lang="en-US" sz="1600" dirty="0"/>
-              <a:t>An additional ”mask” geometry can also be specified. The mask can help to specify the *area* in the example above  </a:t>
+              <a:t>An additional ”mask” geometry can also be specified. The mask can help to specify the *area* in the example above. </a:t>
             </a:r>
           </a:p>
         </p:txBody>
@@ -45200,7 +46012,27 @@
             </a:pPr>
             <a:r>
               <a:rPr lang="en-US" sz="1600" dirty="0"/>
-              <a:t>When checking this rule, a scene is created where the given geometry is colored red, and the reference and mask are colored black. Images of this scene are rendered. You can now check the rendered images for red pixels. Any red pixel = illegal geometry.</a:t>
+              <a:t>When checking this rule, a scene is created where the </a:t>
+            </a:r>
+            <a:r>
+              <a:rPr lang="en-US" sz="1600" b="1" dirty="0">
+                <a:solidFill>
+                  <a:srgbClr val="C00000"/>
+                </a:solidFill>
+              </a:rPr>
+              <a:t>given geometry </a:t>
+            </a:r>
+            <a:r>
+              <a:rPr lang="en-US" sz="1600" dirty="0"/>
+              <a:t>is colored red, and the </a:t>
+            </a:r>
+            <a:r>
+              <a:rPr lang="en-US" sz="1600" b="1" dirty="0"/>
+              <a:t>reference geometry</a:t>
+            </a:r>
+            <a:r>
+              <a:rPr lang="en-US" sz="1600" dirty="0"/>
+              <a:t> is colored black. Images of this scene are rendered. You can now check the rendered images for red pixels. Any red pixel = illegal geometry.</a:t>
             </a:r>
           </a:p>
           <a:p>
@@ -45228,89 +46060,7 @@
             </a:pPr>
             <a:r>
               <a:rPr lang="en-US" sz="1600" b="1" dirty="0"/>
-              <a:t>NB: This rule is sensitive to Z-fighting, so competitors should avoid making geometry that touches the reference volumes!</a:t>
-            </a:r>
-          </a:p>
-        </p:txBody>
-      </p:sp>
-      <p:pic>
-        <p:nvPicPr>
-          <p:cNvPr id="1026" name="Picture 2" descr="Z-Fighting - YouTube">
-            <a:extLst>
-              <a:ext uri="{FF2B5EF4-FFF2-40B4-BE49-F238E27FC236}">
-                <a16:creationId xmlns:a16="http://schemas.microsoft.com/office/drawing/2014/main" id="{DD9F9587-0531-501E-95A9-CFDA089CBD75}"/>
-              </a:ext>
-            </a:extLst>
-          </p:cNvPr>
-          <p:cNvPicPr>
-            <a:picLocks noChangeAspect="1" noChangeArrowheads="1"/>
-          </p:cNvPicPr>
-          <p:nvPr/>
-        </p:nvPicPr>
-        <p:blipFill>
-          <a:blip r:embed="rId2">
-            <a:extLst>
-              <a:ext uri="{28A0092B-C50C-407E-A947-70E740481C1C}">
-                <a14:useLocalDpi xmlns:a14="http://schemas.microsoft.com/office/drawing/2010/main" val="0"/>
-              </a:ext>
-            </a:extLst>
-          </a:blip>
-          <a:srcRect/>
-          <a:stretch>
-            <a:fillRect/>
-          </a:stretch>
-        </p:blipFill>
-        <p:spPr bwMode="auto">
-          <a:xfrm>
-            <a:off x="8758859" y="4679885"/>
-            <a:ext cx="2739042" cy="2054282"/>
-          </a:xfrm>
-          <a:prstGeom prst="rect">
-            <a:avLst/>
-          </a:prstGeom>
-          <a:noFill/>
-          <a:extLst>
-            <a:ext uri="{909E8E84-426E-40DD-AFC4-6F175D3DCCD1}">
-              <a14:hiddenFill xmlns:a14="http://schemas.microsoft.com/office/drawing/2010/main">
-                <a:solidFill>
-                  <a:srgbClr val="FFFFFF"/>
-                </a:solidFill>
-              </a14:hiddenFill>
-            </a:ext>
-          </a:extLst>
-        </p:spPr>
-      </p:pic>
-      <p:sp>
-        <p:nvSpPr>
-          <p:cNvPr id="5" name="Tekstfelt 4">
-            <a:extLst>
-              <a:ext uri="{FF2B5EF4-FFF2-40B4-BE49-F238E27FC236}">
-                <a16:creationId xmlns:a16="http://schemas.microsoft.com/office/drawing/2014/main" id="{AA4C2C93-477C-90D8-CA15-397843409DD0}"/>
-              </a:ext>
-            </a:extLst>
-          </p:cNvPr>
-          <p:cNvSpPr txBox="1"/>
-          <p:nvPr/>
-        </p:nvSpPr>
-        <p:spPr>
-          <a:xfrm>
-            <a:off x="6440847" y="5577181"/>
-            <a:ext cx="2238370" cy="369332"/>
-          </a:xfrm>
-          <a:prstGeom prst="rect">
-            <a:avLst/>
-          </a:prstGeom>
-          <a:noFill/>
-        </p:spPr>
-        <p:txBody>
-          <a:bodyPr wrap="none" rtlCol="0">
-            <a:spAutoFit/>
-          </a:bodyPr>
-          <a:lstStyle/>
-          <a:p>
-            <a:r>
-              <a:rPr lang="en-US" dirty="0"/>
-              <a:t>Z-fighting example → </a:t>
+              <a:t>To avoid Z-fighting issues, 6 copies of the reference geometry are added to the scene. Each translated 1 mm along –x, +x, -y, +y, -z and +z respectively </a:t>
             </a:r>
           </a:p>
         </p:txBody>
@@ -45368,7 +46118,7 @@
           <a:p>
             <a:r>
               <a:rPr lang="en-US" dirty="0"/>
-              <a:t>Obscure rule </a:t>
+              <a:t>Obscure rule, example </a:t>
             </a:r>
           </a:p>
         </p:txBody>
@@ -45430,8 +46180,8 @@
         </p:nvSpPr>
         <p:spPr>
           <a:xfrm>
-            <a:off x="8015226" y="2045617"/>
-            <a:ext cx="2759473" cy="646331"/>
+            <a:off x="6790055" y="2045617"/>
+            <a:ext cx="5209824" cy="646331"/>
           </a:xfrm>
           <a:prstGeom prst="rect">
             <a:avLst/>
@@ -45454,7 +46204,7 @@
             <a:pPr algn="ctr"/>
             <a:r>
               <a:rPr lang="en-US" dirty="0"/>
-              <a:t>(rendered with shadows)</a:t>
+              <a:t>(rendered with shadows and transparent reference)</a:t>
             </a:r>
           </a:p>
         </p:txBody>
@@ -45491,42 +46241,6 @@
               <a:rPr lang="da-DK" dirty="0"/>
               <a:t>Red = illegal</a:t>
             </a:r>
-          </a:p>
-        </p:txBody>
-      </p:sp>
-      <p:sp>
-        <p:nvSpPr>
-          <p:cNvPr id="3" name="TextBox 2">
-            <a:extLst>
-              <a:ext uri="{FF2B5EF4-FFF2-40B4-BE49-F238E27FC236}">
-                <a16:creationId xmlns:a16="http://schemas.microsoft.com/office/drawing/2014/main" id="{7D8CDBEA-48CD-65F8-C43A-582FB26C3B8B}"/>
-              </a:ext>
-            </a:extLst>
-          </p:cNvPr>
-          <p:cNvSpPr txBox="1"/>
-          <p:nvPr/>
-        </p:nvSpPr>
-        <p:spPr>
-          <a:xfrm>
-            <a:off x="6469022" y="1169734"/>
-            <a:ext cx="2577244" cy="369332"/>
-          </a:xfrm>
-          <a:prstGeom prst="rect">
-            <a:avLst/>
-          </a:prstGeom>
-          <a:noFill/>
-        </p:spPr>
-        <p:txBody>
-          <a:bodyPr wrap="none" rtlCol="0">
-            <a:spAutoFit/>
-          </a:bodyPr>
-          <a:lstStyle/>
-          <a:p>
-            <a:r>
-              <a:rPr lang="da-DK" dirty="0"/>
-              <a:t>The rule begin checked: </a:t>
-            </a:r>
-            <a:endParaRPr lang="en-DK" dirty="0"/>
           </a:p>
         </p:txBody>
       </p:sp>
@@ -45684,36 +46398,6 @@
           </a:p>
         </p:txBody>
       </p:sp>
-      <p:pic>
-        <p:nvPicPr>
-          <p:cNvPr id="18" name="Billede 17">
-            <a:extLst>
-              <a:ext uri="{FF2B5EF4-FFF2-40B4-BE49-F238E27FC236}">
-                <a16:creationId xmlns:a16="http://schemas.microsoft.com/office/drawing/2014/main" id="{3D586A4B-ADAC-2A41-6BBF-F02F84C9D67D}"/>
-              </a:ext>
-            </a:extLst>
-          </p:cNvPr>
-          <p:cNvPicPr>
-            <a:picLocks noChangeAspect="1"/>
-          </p:cNvPicPr>
-          <p:nvPr/>
-        </p:nvPicPr>
-        <p:blipFill>
-          <a:blip r:embed="rId4"/>
-          <a:stretch>
-            <a:fillRect/>
-          </a:stretch>
-        </p:blipFill>
-        <p:spPr>
-          <a:xfrm>
-            <a:off x="9199778" y="592253"/>
-            <a:ext cx="2678707" cy="1429071"/>
-          </a:xfrm>
-          <a:prstGeom prst="rect">
-            <a:avLst/>
-          </a:prstGeom>
-        </p:spPr>
-      </p:pic>
     </p:spTree>
     <p:extLst>
       <p:ext uri="{BB962C8B-B14F-4D97-AF65-F5344CB8AC3E}">
@@ -45791,7 +46475,7 @@
         <p:spPr>
           <a:xfrm>
             <a:off x="838201" y="1690688"/>
-            <a:ext cx="5164018" cy="4923693"/>
+            <a:ext cx="5164018" cy="4976077"/>
           </a:xfrm>
         </p:spPr>
         <p:txBody>
@@ -45804,8 +46488,24 @@
               <a:buNone/>
             </a:pPr>
             <a:r>
-              <a:rPr lang="da-DK" sz="1600" dirty="0"/>
-              <a:t>”Number of sections” –rule can be used to count number of sections in frontwings, rearwings etc.  </a:t>
+              <a:rPr lang="en-US" sz="1600" noProof="0" dirty="0"/>
+              <a:t>”Number of sections” –rule can be used to count number of sections in </a:t>
+            </a:r>
+            <a:r>
+              <a:rPr lang="en-US" sz="1600" noProof="0" dirty="0" err="1"/>
+              <a:t>frontwings</a:t>
+            </a:r>
+            <a:r>
+              <a:rPr lang="en-US" sz="1600" noProof="0" dirty="0"/>
+              <a:t>, </a:t>
+            </a:r>
+            <a:r>
+              <a:rPr lang="en-US" sz="1600" noProof="0" dirty="0" err="1"/>
+              <a:t>rearwings</a:t>
+            </a:r>
+            <a:r>
+              <a:rPr lang="en-US" sz="1600" noProof="0" dirty="0"/>
+              <a:t> etc.  </a:t>
             </a:r>
           </a:p>
           <a:p>
@@ -45813,64 +46513,16 @@
               <a:buNone/>
             </a:pPr>
             <a:r>
-              <a:rPr lang="da-DK" sz="1600" dirty="0"/>
+              <a:rPr lang="en-US" sz="1600" noProof="0" dirty="0"/>
               <a:t>It works by </a:t>
             </a:r>
             <a:r>
-              <a:rPr lang="da-DK" sz="1600" dirty="0" err="1"/>
-              <a:t>sectioning</a:t>
-            </a:r>
-            <a:r>
-              <a:rPr lang="da-DK" sz="1600" dirty="0"/>
-              <a:t> the </a:t>
-            </a:r>
-            <a:r>
-              <a:rPr lang="da-DK" sz="1600" dirty="0" err="1"/>
-              <a:t>geometry</a:t>
-            </a:r>
-            <a:r>
-              <a:rPr lang="da-DK" sz="1600" dirty="0"/>
-              <a:t> with a </a:t>
-            </a:r>
-            <a:r>
-              <a:rPr lang="da-DK" sz="1600" dirty="0" err="1"/>
-              <a:t>number</a:t>
-            </a:r>
-            <a:r>
-              <a:rPr lang="da-DK" sz="1600" dirty="0"/>
-              <a:t> of planes. The planes </a:t>
-            </a:r>
-            <a:r>
-              <a:rPr lang="da-DK" sz="1600" dirty="0" err="1"/>
-              <a:t>are</a:t>
-            </a:r>
-            <a:r>
-              <a:rPr lang="da-DK" sz="1600" dirty="0"/>
-              <a:t> </a:t>
-            </a:r>
-            <a:r>
-              <a:rPr lang="da-DK" sz="1600" dirty="0" err="1"/>
-              <a:t>defined</a:t>
-            </a:r>
-            <a:r>
-              <a:rPr lang="da-DK" sz="1600" dirty="0"/>
-              <a:t> with a normal </a:t>
-            </a:r>
-            <a:r>
-              <a:rPr lang="da-DK" sz="1600" dirty="0" err="1"/>
-              <a:t>vector</a:t>
-            </a:r>
-            <a:r>
-              <a:rPr lang="da-DK" sz="1600" dirty="0"/>
-              <a:t>, and an </a:t>
-            </a:r>
-            <a:r>
-              <a:rPr lang="da-DK" sz="1600" dirty="0" err="1"/>
-              <a:t>origin</a:t>
-            </a:r>
-            <a:r>
-              <a:rPr lang="da-DK" sz="1600" dirty="0"/>
-              <a:t> point. </a:t>
+              <a:rPr lang="en-US" sz="1600" i="1" noProof="0" dirty="0"/>
+              <a:t>cutting</a:t>
+            </a:r>
+            <a:r>
+              <a:rPr lang="en-US" sz="1600" noProof="0" dirty="0"/>
+              <a:t> the geometry with a number of planes. The planes are defined with a normal vector, and an origin point. </a:t>
             </a:r>
           </a:p>
           <a:p>
@@ -45878,32 +46530,8 @@
               <a:buNone/>
             </a:pPr>
             <a:r>
-              <a:rPr lang="da-DK" sz="1600" dirty="0"/>
-              <a:t>The normal </a:t>
-            </a:r>
-            <a:r>
-              <a:rPr lang="da-DK" sz="1600" dirty="0" err="1"/>
-              <a:t>vector</a:t>
-            </a:r>
-            <a:r>
-              <a:rPr lang="da-DK" sz="1600" dirty="0"/>
-              <a:t> is </a:t>
-            </a:r>
-            <a:r>
-              <a:rPr lang="da-DK" sz="1600" dirty="0" err="1"/>
-              <a:t>specified</a:t>
-            </a:r>
-            <a:r>
-              <a:rPr lang="da-DK" sz="1600" dirty="0"/>
-              <a:t> in the </a:t>
-            </a:r>
-            <a:r>
-              <a:rPr lang="da-DK" sz="1600" dirty="0" err="1"/>
-              <a:t>rules</a:t>
-            </a:r>
-            <a:r>
-              <a:rPr lang="da-DK" sz="1600" dirty="0"/>
-              <a:t>. </a:t>
+              <a:rPr lang="en-US" sz="1600" noProof="0" dirty="0"/>
+              <a:t>The normal vector is specified in the rules. </a:t>
             </a:r>
           </a:p>
           <a:p>
@@ -45911,24 +46539,8 @@
               <a:buNone/>
             </a:pPr>
             <a:r>
-              <a:rPr lang="da-DK" sz="1600" dirty="0"/>
-              <a:t>     for </a:t>
-            </a:r>
-            <a:r>
-              <a:rPr lang="da-DK" sz="1600" dirty="0" err="1"/>
-              <a:t>example</a:t>
-            </a:r>
-            <a:r>
-              <a:rPr lang="da-DK" sz="1600" dirty="0"/>
-              <a:t> (0, 1, 0) for y-</a:t>
-            </a:r>
-            <a:r>
-              <a:rPr lang="da-DK" sz="1600" dirty="0" err="1"/>
-              <a:t>sections</a:t>
-            </a:r>
-            <a:r>
-              <a:rPr lang="da-DK" sz="1600" dirty="0"/>
-              <a:t>.  </a:t>
+              <a:rPr lang="en-US" sz="1600" noProof="0" dirty="0"/>
+              <a:t>     for example (0, 1, 0) for y-sections.  </a:t>
             </a:r>
           </a:p>
           <a:p>
@@ -45936,128 +46548,40 @@
               <a:buNone/>
             </a:pPr>
             <a:r>
-              <a:rPr lang="da-DK" sz="1600" dirty="0"/>
-              <a:t>The </a:t>
-            </a:r>
-            <a:r>
-              <a:rPr lang="da-DK" sz="1600" dirty="0" err="1"/>
-              <a:t>origin</a:t>
-            </a:r>
-            <a:r>
-              <a:rPr lang="da-DK" sz="1600" dirty="0"/>
-              <a:t> points </a:t>
-            </a:r>
-            <a:r>
-              <a:rPr lang="da-DK" sz="1600" dirty="0" err="1"/>
-              <a:t>can</a:t>
-            </a:r>
-            <a:r>
-              <a:rPr lang="da-DK" sz="1600" dirty="0"/>
-              <a:t> </a:t>
-            </a:r>
-            <a:r>
-              <a:rPr lang="da-DK" sz="1600" dirty="0" err="1"/>
-              <a:t>be</a:t>
-            </a:r>
-            <a:r>
-              <a:rPr lang="da-DK" sz="1600" dirty="0"/>
-              <a:t> </a:t>
-            </a:r>
-            <a:r>
-              <a:rPr lang="da-DK" sz="1600" dirty="0" err="1"/>
-              <a:t>defined</a:t>
-            </a:r>
-            <a:r>
-              <a:rPr lang="da-DK" sz="1600" dirty="0"/>
-              <a:t> </a:t>
-            </a:r>
-            <a:r>
-              <a:rPr lang="da-DK" sz="1600" dirty="0" err="1"/>
-              <a:t>either</a:t>
-            </a:r>
-            <a:r>
-              <a:rPr lang="da-DK" sz="1600" dirty="0"/>
-              <a:t> as a </a:t>
-            </a:r>
-            <a:r>
-              <a:rPr lang="da-DK" sz="1600" dirty="0" err="1"/>
-              <a:t>strict</a:t>
-            </a:r>
-            <a:r>
-              <a:rPr lang="da-DK" sz="1600" dirty="0"/>
-              <a:t> list of points, or as a ”</a:t>
-            </a:r>
-            <a:r>
-              <a:rPr lang="da-DK" sz="1600" dirty="0" err="1"/>
-              <a:t>semi-random</a:t>
-            </a:r>
-            <a:r>
-              <a:rPr lang="da-DK" sz="1600" dirty="0"/>
-              <a:t>” list of points in an interval. For </a:t>
-            </a:r>
-            <a:r>
-              <a:rPr lang="da-DK" sz="1600" dirty="0" err="1"/>
-              <a:t>semi-random</a:t>
-            </a:r>
-            <a:r>
-              <a:rPr lang="da-DK" sz="1600" dirty="0"/>
-              <a:t> sampling a ”</a:t>
-            </a:r>
-            <a:r>
-              <a:rPr lang="da-DK" sz="1600" dirty="0" err="1"/>
-              <a:t>maximum</a:t>
-            </a:r>
-            <a:r>
-              <a:rPr lang="da-DK" sz="1600" dirty="0"/>
-              <a:t> </a:t>
-            </a:r>
-            <a:r>
-              <a:rPr lang="da-DK" sz="1600" dirty="0" err="1"/>
-              <a:t>unprobed</a:t>
-            </a:r>
-            <a:r>
-              <a:rPr lang="da-DK" sz="1600" dirty="0"/>
-              <a:t> interval” must </a:t>
-            </a:r>
-            <a:r>
-              <a:rPr lang="da-DK" sz="1600" dirty="0" err="1"/>
-              <a:t>be</a:t>
-            </a:r>
-            <a:r>
-              <a:rPr lang="da-DK" sz="1600" dirty="0"/>
-              <a:t> </a:t>
-            </a:r>
-            <a:r>
-              <a:rPr lang="da-DK" sz="1600" dirty="0" err="1"/>
-              <a:t>defined</a:t>
-            </a:r>
-            <a:r>
-              <a:rPr lang="da-DK" sz="1600" dirty="0"/>
-              <a:t>, </a:t>
-            </a:r>
-            <a:r>
-              <a:rPr lang="da-DK" sz="1600" dirty="0" err="1"/>
-              <a:t>this</a:t>
-            </a:r>
-            <a:r>
-              <a:rPr lang="da-DK" sz="1600" dirty="0"/>
-              <a:t> is the </a:t>
-            </a:r>
-            <a:r>
-              <a:rPr lang="da-DK" sz="1600" dirty="0" err="1"/>
-              <a:t>maximum</a:t>
-            </a:r>
-            <a:r>
-              <a:rPr lang="da-DK" sz="1600" dirty="0"/>
-              <a:t> distance </a:t>
-            </a:r>
-            <a:r>
-              <a:rPr lang="da-DK" sz="1600" dirty="0" err="1"/>
-              <a:t>between</a:t>
-            </a:r>
-            <a:r>
-              <a:rPr lang="da-DK" sz="1600" dirty="0"/>
-              <a:t> planes. </a:t>
+              <a:rPr lang="en-US" sz="1600" noProof="0" dirty="0"/>
+              <a:t>The origin points can be defined either as a strict </a:t>
+            </a:r>
+            <a:r>
+              <a:rPr lang="en-US" sz="1600" b="1" i="1" noProof="0" dirty="0"/>
+              <a:t>list of specific</a:t>
+            </a:r>
+            <a:r>
+              <a:rPr lang="en-US" sz="1600" noProof="0" dirty="0"/>
+              <a:t> points, or as a </a:t>
+            </a:r>
+            <a:r>
+              <a:rPr lang="en-US" sz="1600" b="1" i="1" noProof="0" dirty="0"/>
+              <a:t>”semi-random” </a:t>
+            </a:r>
+            <a:r>
+              <a:rPr lang="en-US" sz="1600" noProof="0" dirty="0"/>
+              <a:t>list of points in an interval. For semi-random sampling a </a:t>
+            </a:r>
+            <a:r>
+              <a:rPr lang="en-US" sz="1600" b="1" i="1" noProof="0" dirty="0"/>
+              <a:t>”maximum unprobed interval” </a:t>
+            </a:r>
+            <a:r>
+              <a:rPr lang="en-US" sz="1600" noProof="0" dirty="0"/>
+              <a:t>is given, this is the maximum distance between planes in the </a:t>
+            </a:r>
+            <a:r>
+              <a:rPr lang="en-US" sz="1600" b="1" i="1" noProof="0" dirty="0" err="1"/>
+              <a:t>sampling_interval</a:t>
+            </a:r>
+            <a:r>
+              <a:rPr lang="en-US" sz="1600" noProof="0" dirty="0"/>
+              <a:t>. </a:t>
             </a:r>
           </a:p>
           <a:p>
@@ -46065,72 +46589,8 @@
               <a:buNone/>
             </a:pPr>
             <a:r>
-              <a:rPr lang="da-DK" sz="1600" dirty="0"/>
-              <a:t>The 3d </a:t>
-            </a:r>
-            <a:r>
-              <a:rPr lang="da-DK" sz="1600" dirty="0" err="1"/>
-              <a:t>coordinates</a:t>
-            </a:r>
-            <a:r>
-              <a:rPr lang="da-DK" sz="1600" dirty="0"/>
-              <a:t> of the </a:t>
-            </a:r>
-            <a:r>
-              <a:rPr lang="da-DK" sz="1600" dirty="0" err="1"/>
-              <a:t>origin</a:t>
-            </a:r>
-            <a:r>
-              <a:rPr lang="da-DK" sz="1600" dirty="0"/>
-              <a:t> points </a:t>
-            </a:r>
-            <a:r>
-              <a:rPr lang="da-DK" sz="1600" dirty="0" err="1"/>
-              <a:t>are</a:t>
-            </a:r>
-            <a:r>
-              <a:rPr lang="da-DK" sz="1600" dirty="0"/>
-              <a:t> </a:t>
-            </a:r>
-            <a:r>
-              <a:rPr lang="da-DK" sz="1600" dirty="0" err="1"/>
-              <a:t>found</a:t>
-            </a:r>
-            <a:r>
-              <a:rPr lang="da-DK" sz="1600" dirty="0"/>
-              <a:t> by </a:t>
-            </a:r>
-            <a:r>
-              <a:rPr lang="da-DK" sz="1600" dirty="0" err="1"/>
-              <a:t>multiplying</a:t>
-            </a:r>
-            <a:r>
-              <a:rPr lang="da-DK" sz="1600" dirty="0"/>
-              <a:t> </a:t>
-            </a:r>
-            <a:r>
-              <a:rPr lang="da-DK" sz="1600" dirty="0" err="1"/>
-              <a:t>each</a:t>
-            </a:r>
-            <a:r>
-              <a:rPr lang="da-DK" sz="1600" dirty="0"/>
-              <a:t> </a:t>
-            </a:r>
-            <a:r>
-              <a:rPr lang="da-DK" sz="1600" dirty="0" err="1"/>
-              <a:t>scalar</a:t>
-            </a:r>
-            <a:r>
-              <a:rPr lang="da-DK" sz="1600" dirty="0"/>
-              <a:t> in the list with the normal </a:t>
-            </a:r>
-            <a:r>
-              <a:rPr lang="da-DK" sz="1600" dirty="0" err="1"/>
-              <a:t>vector</a:t>
-            </a:r>
-            <a:r>
-              <a:rPr lang="da-DK" sz="1600" dirty="0"/>
-              <a:t>. </a:t>
+              <a:rPr lang="en-US" sz="1600" noProof="0" dirty="0"/>
+              <a:t>The 3d coordinates of the origin points are found by multiplying each scalar in the list with the normal vector of the plane. </a:t>
             </a:r>
           </a:p>
           <a:p>
@@ -46138,64 +46598,8 @@
               <a:buNone/>
             </a:pPr>
             <a:r>
-              <a:rPr lang="da-DK" sz="1600" dirty="0"/>
-              <a:t>An image of the cut </a:t>
-            </a:r>
-            <a:r>
-              <a:rPr lang="da-DK" sz="1600" dirty="0" err="1"/>
-              <a:t>section</a:t>
-            </a:r>
-            <a:r>
-              <a:rPr lang="da-DK" sz="1600" dirty="0"/>
-              <a:t> is rendered. </a:t>
-            </a:r>
-            <a:r>
-              <a:rPr lang="da-DK" sz="1600" dirty="0" err="1"/>
-              <a:t>Then</a:t>
-            </a:r>
-            <a:r>
-              <a:rPr lang="da-DK" sz="1600" dirty="0"/>
-              <a:t> it </a:t>
-            </a:r>
-            <a:r>
-              <a:rPr lang="da-DK" sz="1600" dirty="0" err="1"/>
-              <a:t>counts</a:t>
-            </a:r>
-            <a:r>
-              <a:rPr lang="da-DK" sz="1600" dirty="0"/>
-              <a:t> the </a:t>
-            </a:r>
-            <a:r>
-              <a:rPr lang="da-DK" sz="1600" dirty="0" err="1"/>
-              <a:t>number</a:t>
-            </a:r>
-            <a:r>
-              <a:rPr lang="da-DK" sz="1600" dirty="0"/>
-              <a:t> of </a:t>
-            </a:r>
-            <a:r>
-              <a:rPr lang="da-DK" sz="1600" dirty="0" err="1"/>
-              <a:t>sections</a:t>
-            </a:r>
-            <a:r>
-              <a:rPr lang="da-DK" sz="1600" dirty="0"/>
-              <a:t> visible in the image. (</a:t>
-            </a:r>
-            <a:r>
-              <a:rPr lang="da-DK" sz="1600" dirty="0" err="1"/>
-              <a:t>see</a:t>
-            </a:r>
-            <a:r>
-              <a:rPr lang="da-DK" sz="1600" dirty="0"/>
-              <a:t> </a:t>
-            </a:r>
-            <a:r>
-              <a:rPr lang="da-DK" sz="1600" dirty="0" err="1"/>
-              <a:t>next</a:t>
-            </a:r>
-            <a:r>
-              <a:rPr lang="da-DK" sz="1600" dirty="0"/>
-              <a:t> slide) </a:t>
+              <a:rPr lang="en-US" sz="1600" noProof="0" dirty="0"/>
+              <a:t>An image of the cut section is rendered. Then the number of sections visible in the image are counted. (see next slide) </a:t>
             </a:r>
           </a:p>
           <a:p>
@@ -46203,95 +46607,15 @@
               <a:buNone/>
             </a:pPr>
             <a:r>
-              <a:rPr lang="da-DK" sz="1600" b="1" dirty="0"/>
-              <a:t>NB! </a:t>
-            </a:r>
-            <a:r>
-              <a:rPr lang="da-DK" sz="1600" b="1" dirty="0" err="1"/>
-              <a:t>Since</a:t>
-            </a:r>
-            <a:r>
-              <a:rPr lang="da-DK" sz="1600" b="1" dirty="0"/>
-              <a:t> it </a:t>
-            </a:r>
-            <a:r>
-              <a:rPr lang="da-DK" sz="1600" b="1" dirty="0" err="1"/>
-              <a:t>only</a:t>
-            </a:r>
-            <a:r>
-              <a:rPr lang="da-DK" sz="1600" b="1" dirty="0"/>
-              <a:t> checks a </a:t>
-            </a:r>
-            <a:r>
-              <a:rPr lang="da-DK" sz="1600" b="1" dirty="0" err="1"/>
-              <a:t>limited</a:t>
-            </a:r>
-            <a:r>
-              <a:rPr lang="da-DK" sz="1600" b="1" dirty="0"/>
-              <a:t> </a:t>
-            </a:r>
-            <a:r>
-              <a:rPr lang="da-DK" sz="1600" b="1" dirty="0" err="1"/>
-              <a:t>number</a:t>
-            </a:r>
-            <a:r>
-              <a:rPr lang="da-DK" sz="1600" b="1" dirty="0"/>
-              <a:t> of </a:t>
-            </a:r>
-            <a:r>
-              <a:rPr lang="da-DK" sz="1600" b="1" dirty="0" err="1"/>
-              <a:t>sections</a:t>
-            </a:r>
-            <a:r>
-              <a:rPr lang="da-DK" sz="1600" b="1" dirty="0"/>
-              <a:t>, small </a:t>
-            </a:r>
-            <a:r>
-              <a:rPr lang="da-DK" sz="1600" b="1" dirty="0" err="1"/>
-              <a:t>infringements</a:t>
-            </a:r>
-            <a:r>
-              <a:rPr lang="da-DK" sz="1600" b="1" dirty="0"/>
-              <a:t> </a:t>
-            </a:r>
-            <a:r>
-              <a:rPr lang="da-DK" sz="1600" b="1" dirty="0" err="1"/>
-              <a:t>may</a:t>
-            </a:r>
-            <a:r>
-              <a:rPr lang="da-DK" sz="1600" b="1" dirty="0"/>
-              <a:t> or </a:t>
-            </a:r>
-            <a:r>
-              <a:rPr lang="da-DK" sz="1600" b="1" dirty="0" err="1"/>
-              <a:t>may</a:t>
-            </a:r>
-            <a:r>
-              <a:rPr lang="da-DK" sz="1600" b="1" dirty="0"/>
-              <a:t> not </a:t>
-            </a:r>
-            <a:r>
-              <a:rPr lang="da-DK" sz="1600" b="1" dirty="0" err="1"/>
-              <a:t>be</a:t>
-            </a:r>
-            <a:r>
-              <a:rPr lang="da-DK" sz="1600" b="1" dirty="0"/>
-              <a:t> </a:t>
-            </a:r>
-            <a:r>
-              <a:rPr lang="da-DK" sz="1600" b="1" dirty="0" err="1"/>
-              <a:t>caught</a:t>
-            </a:r>
-            <a:r>
-              <a:rPr lang="da-DK" sz="1600" b="1" dirty="0"/>
-              <a:t>! </a:t>
+              <a:rPr lang="en-US" sz="1600" b="1" noProof="0" dirty="0"/>
+              <a:t>NB! Since it only checks a limited number of sections, small infringements may or may not be caught! </a:t>
             </a:r>
           </a:p>
           <a:p>
             <a:pPr marL="0" indent="0">
               <a:buNone/>
             </a:pPr>
-            <a:endParaRPr lang="da-DK" sz="1600" dirty="0"/>
+            <a:endParaRPr lang="en-US" sz="1600" noProof="0" dirty="0"/>
           </a:p>
         </p:txBody>
       </p:sp>
@@ -47428,7 +47752,15 @@
             </a:pPr>
             <a:r>
               <a:rPr lang="en-US" sz="1600" noProof="0" dirty="0"/>
-              <a:t>Another method could be to simply count the number of red sections. I decided against this approach because you often have overlapping geometries (because it is good for meshing). But you don't want to count any “internal” section as a section. This way you only count the number of sections in contact with the external flow. Imo this is closer to ideal. </a:t>
+              <a:t>Another method could be to simply count the number of red sections. I decided against this approach because you often have overlapping geometries (because it is good for meshing). You don't want to count </a:t>
+            </a:r>
+            <a:r>
+              <a:rPr lang="en-US" sz="1600" dirty="0"/>
+              <a:t>these overlapping regions</a:t>
+            </a:r>
+            <a:r>
+              <a:rPr lang="en-US" sz="1600" noProof="0" dirty="0"/>
+              <a:t> as a section. This way you only count the number of sections in contact with the external flow. Imo this is closer to ideal. </a:t>
             </a:r>
           </a:p>
           <a:p>
@@ -47518,7 +47850,7 @@
           <p:cNvPr id="2" name="Titel 1">
             <a:extLst>
               <a:ext uri="{FF2B5EF4-FFF2-40B4-BE49-F238E27FC236}">
-                <a16:creationId xmlns:a16="http://schemas.microsoft.com/office/drawing/2014/main" id="{78779485-A8AA-95AF-2752-C5851A0111E5}"/>
+                <a16:creationId xmlns:a16="http://schemas.microsoft.com/office/drawing/2014/main" id="{19EACA2C-4245-8E19-6AF1-CC3224A68987}"/>
               </a:ext>
             </a:extLst>
           </p:cNvPr>
@@ -47526,7 +47858,7 @@
             <a:spLocks noGrp="1"/>
           </p:cNvSpPr>
           <p:nvPr>
-            <p:ph type="ctrTitle"/>
+            <p:ph type="title"/>
           </p:nvPr>
         </p:nvSpPr>
         <p:spPr/>
@@ -47536,17 +47868,33 @@
           <a:p>
             <a:r>
               <a:rPr lang="da-DK" dirty="0"/>
-              <a:t>Part 2</a:t>
+              <a:t>Top/</a:t>
+            </a:r>
+            <a:r>
+              <a:rPr lang="da-DK" dirty="0" err="1"/>
+              <a:t>bottom</a:t>
+            </a:r>
+            <a:r>
+              <a:rPr lang="da-DK" dirty="0"/>
+              <a:t> </a:t>
+            </a:r>
+            <a:r>
+              <a:rPr lang="da-DK" dirty="0" err="1"/>
+              <a:t>visibility</a:t>
+            </a:r>
+            <a:r>
+              <a:rPr lang="da-DK" dirty="0"/>
+              <a:t> </a:t>
             </a:r>
           </a:p>
         </p:txBody>
       </p:sp>
       <p:sp>
         <p:nvSpPr>
-          <p:cNvPr id="3" name="Undertitel 2">
+          <p:cNvPr id="3" name="Pladsholder til indhold 2">
             <a:extLst>
               <a:ext uri="{FF2B5EF4-FFF2-40B4-BE49-F238E27FC236}">
-                <a16:creationId xmlns:a16="http://schemas.microsoft.com/office/drawing/2014/main" id="{FB6D1EAF-4116-2747-FEE8-2D964FC616C9}"/>
+                <a16:creationId xmlns:a16="http://schemas.microsoft.com/office/drawing/2014/main" id="{B7137BAD-0618-E5FE-69CC-4F7921D1488F}"/>
               </a:ext>
             </a:extLst>
           </p:cNvPr>
@@ -47554,44 +47902,567 @@
             <a:spLocks noGrp="1"/>
           </p:cNvSpPr>
           <p:nvPr>
-            <p:ph type="subTitle" idx="1"/>
+            <p:ph idx="1"/>
           </p:nvPr>
         </p:nvSpPr>
-        <p:spPr/>
+        <p:spPr>
+          <a:xfrm>
+            <a:off x="838200" y="1690688"/>
+            <a:ext cx="10515600" cy="4351338"/>
+          </a:xfrm>
+        </p:spPr>
         <p:txBody>
-          <a:bodyPr/>
+          <a:bodyPr>
+            <a:normAutofit/>
+          </a:bodyPr>
           <a:lstStyle/>
           <a:p>
+            <a:pPr marL="0" indent="0">
+              <a:buNone/>
+            </a:pPr>
+            <a:r>
+              <a:rPr lang="en-US" sz="2000" noProof="0" dirty="0"/>
+              <a:t>Top/bottom visibility checks that every surface of the part is either visible from above or below. This rule takes sections of the given geometry, like the number of sections rule, but processes the images differently. </a:t>
+            </a:r>
+          </a:p>
+          <a:p>
+            <a:pPr marL="0" indent="0">
+              <a:buNone/>
+            </a:pPr>
+            <a:r>
+              <a:rPr lang="en-US" sz="2000" noProof="0" dirty="0"/>
+              <a:t>After ”bucket-filling” from a corner, it looks at every column of pixels in the image. Specifically, it counts the number of times the pixel value changes from black to white or white to black. If it counts more than 2 of these intersections then that suggest some overhang, and that means some surfaces must not be visible from above or below.   </a:t>
+            </a:r>
+          </a:p>
+        </p:txBody>
+      </p:sp>
+      <p:pic>
+        <p:nvPicPr>
+          <p:cNvPr id="4" name="Billede 3">
+            <a:extLst>
+              <a:ext uri="{FF2B5EF4-FFF2-40B4-BE49-F238E27FC236}">
+                <a16:creationId xmlns:a16="http://schemas.microsoft.com/office/drawing/2014/main" id="{AB348A50-EDF3-3964-3A1E-93D986AEE0CC}"/>
+              </a:ext>
+            </a:extLst>
+          </p:cNvPr>
+          <p:cNvPicPr>
+            <a:picLocks noChangeAspect="1"/>
+          </p:cNvPicPr>
+          <p:nvPr/>
+        </p:nvPicPr>
+        <p:blipFill>
+          <a:blip r:embed="rId2"/>
+          <a:stretch>
+            <a:fillRect/>
+          </a:stretch>
+        </p:blipFill>
+        <p:spPr>
+          <a:xfrm>
+            <a:off x="4812126" y="4573512"/>
+            <a:ext cx="2071108" cy="1164998"/>
+          </a:xfrm>
+          <a:prstGeom prst="rect">
+            <a:avLst/>
+          </a:prstGeom>
+          <a:ln>
+            <a:solidFill>
+              <a:srgbClr val="C00000"/>
+            </a:solidFill>
+          </a:ln>
+        </p:spPr>
+      </p:pic>
+      <p:pic>
+        <p:nvPicPr>
+          <p:cNvPr id="5" name="Billede 4" descr="Et billede, der indeholder mørke, sort, kunst&#10;&#10;Automatisk genereret beskrivelse">
+            <a:extLst>
+              <a:ext uri="{FF2B5EF4-FFF2-40B4-BE49-F238E27FC236}">
+                <a16:creationId xmlns:a16="http://schemas.microsoft.com/office/drawing/2014/main" id="{0F24ABAF-9C08-7442-C5CA-C5EFA1D0EEC0}"/>
+              </a:ext>
+            </a:extLst>
+          </p:cNvPr>
+          <p:cNvPicPr>
+            <a:picLocks noChangeAspect="1"/>
+          </p:cNvPicPr>
+          <p:nvPr/>
+        </p:nvPicPr>
+        <p:blipFill>
+          <a:blip r:embed="rId3">
+            <a:extLst>
+              <a:ext uri="{28A0092B-C50C-407E-A947-70E740481C1C}">
+                <a14:useLocalDpi xmlns:a14="http://schemas.microsoft.com/office/drawing/2010/main" val="0"/>
+              </a:ext>
+            </a:extLst>
+          </a:blip>
+          <a:stretch>
+            <a:fillRect/>
+          </a:stretch>
+        </p:blipFill>
+        <p:spPr>
+          <a:xfrm>
+            <a:off x="2348365" y="4573512"/>
+            <a:ext cx="2071106" cy="1164998"/>
+          </a:xfrm>
+          <a:prstGeom prst="rect">
+            <a:avLst/>
+          </a:prstGeom>
+          <a:ln>
+            <a:solidFill>
+              <a:srgbClr val="C00000"/>
+            </a:solidFill>
+          </a:ln>
+        </p:spPr>
+      </p:pic>
+      <p:sp>
+        <p:nvSpPr>
+          <p:cNvPr id="6" name="Tekstfelt 5">
+            <a:extLst>
+              <a:ext uri="{FF2B5EF4-FFF2-40B4-BE49-F238E27FC236}">
+                <a16:creationId xmlns:a16="http://schemas.microsoft.com/office/drawing/2014/main" id="{EBE80821-8307-69F7-0437-4A709E25DBF9}"/>
+              </a:ext>
+            </a:extLst>
+          </p:cNvPr>
+          <p:cNvSpPr txBox="1"/>
+          <p:nvPr/>
+        </p:nvSpPr>
+        <p:spPr>
+          <a:xfrm>
+            <a:off x="2372865" y="5749773"/>
+            <a:ext cx="1902765" cy="369332"/>
+          </a:xfrm>
+          <a:prstGeom prst="rect">
+            <a:avLst/>
+          </a:prstGeom>
+          <a:noFill/>
+        </p:spPr>
+        <p:txBody>
+          <a:bodyPr wrap="none" rtlCol="0">
+            <a:spAutoFit/>
+          </a:bodyPr>
+          <a:lstStyle/>
+          <a:p>
+            <a:r>
+              <a:rPr lang="da-DK" dirty="0"/>
+              <a:t>(8bit </a:t>
+            </a:r>
             <a:r>
               <a:rPr lang="da-DK" dirty="0" err="1"/>
-              <a:t>Mostly</a:t>
+              <a:t>RGBa</a:t>
             </a:r>
             <a:r>
               <a:rPr lang="da-DK" dirty="0"/>
-              <a:t> relevant to </a:t>
+              <a:t> array) </a:t>
+            </a:r>
+          </a:p>
+        </p:txBody>
+      </p:sp>
+      <p:sp>
+        <p:nvSpPr>
+          <p:cNvPr id="7" name="Tekstfelt 6">
+            <a:extLst>
+              <a:ext uri="{FF2B5EF4-FFF2-40B4-BE49-F238E27FC236}">
+                <a16:creationId xmlns:a16="http://schemas.microsoft.com/office/drawing/2014/main" id="{19E61AB9-B630-6E63-BD59-D616D112D7EC}"/>
+              </a:ext>
+            </a:extLst>
+          </p:cNvPr>
+          <p:cNvSpPr txBox="1"/>
+          <p:nvPr/>
+        </p:nvSpPr>
+        <p:spPr>
+          <a:xfrm>
+            <a:off x="5002608" y="5749773"/>
+            <a:ext cx="1734064" cy="369332"/>
+          </a:xfrm>
+          <a:prstGeom prst="rect">
+            <a:avLst/>
+          </a:prstGeom>
+          <a:noFill/>
+        </p:spPr>
+        <p:txBody>
+          <a:bodyPr wrap="none" rtlCol="0">
+            <a:spAutoFit/>
+          </a:bodyPr>
+          <a:lstStyle/>
+          <a:p>
+            <a:r>
+              <a:rPr lang="da-DK" dirty="0"/>
+              <a:t>(</a:t>
             </a:r>
             <a:r>
               <a:rPr lang="da-DK" dirty="0" err="1"/>
-              <a:t>staff</a:t>
+              <a:t>Boolean</a:t>
             </a:r>
             <a:r>
               <a:rPr lang="da-DK" dirty="0"/>
-              <a:t>/</a:t>
-            </a:r>
+              <a:t> array) </a:t>
+            </a:r>
+          </a:p>
+        </p:txBody>
+      </p:sp>
+      <p:sp>
+        <p:nvSpPr>
+          <p:cNvPr id="8" name="Tekstfelt 7">
+            <a:extLst>
+              <a:ext uri="{FF2B5EF4-FFF2-40B4-BE49-F238E27FC236}">
+                <a16:creationId xmlns:a16="http://schemas.microsoft.com/office/drawing/2014/main" id="{F963D624-228B-89BF-4197-6F74762C14DD}"/>
+              </a:ext>
+            </a:extLst>
+          </p:cNvPr>
+          <p:cNvSpPr txBox="1"/>
+          <p:nvPr/>
+        </p:nvSpPr>
+        <p:spPr>
+          <a:xfrm>
+            <a:off x="5002608" y="4177925"/>
+            <a:ext cx="1690143" cy="369332"/>
+          </a:xfrm>
+          <a:prstGeom prst="rect">
+            <a:avLst/>
+          </a:prstGeom>
+          <a:noFill/>
+        </p:spPr>
+        <p:txBody>
+          <a:bodyPr wrap="none" rtlCol="0">
+            <a:spAutoFit/>
+          </a:bodyPr>
+          <a:lstStyle/>
+          <a:p>
             <a:r>
               <a:rPr lang="da-DK" dirty="0" err="1"/>
-              <a:t>contributors</a:t>
-            </a:r>
+              <a:t>Convert</a:t>
+            </a:r>
+            <a:r>
+              <a:rPr lang="da-DK" dirty="0"/>
+              <a:t> to B/W</a:t>
+            </a:r>
+          </a:p>
+        </p:txBody>
+      </p:sp>
+      <p:pic>
+        <p:nvPicPr>
+          <p:cNvPr id="9" name="Billede 8">
+            <a:extLst>
+              <a:ext uri="{FF2B5EF4-FFF2-40B4-BE49-F238E27FC236}">
+                <a16:creationId xmlns:a16="http://schemas.microsoft.com/office/drawing/2014/main" id="{A4A673B6-22A0-5152-BB78-F65E5DA14234}"/>
+              </a:ext>
+            </a:extLst>
+          </p:cNvPr>
+          <p:cNvPicPr>
+            <a:picLocks noChangeAspect="1"/>
+          </p:cNvPicPr>
+          <p:nvPr/>
+        </p:nvPicPr>
+        <p:blipFill>
+          <a:blip r:embed="rId4"/>
+          <a:stretch>
+            <a:fillRect/>
+          </a:stretch>
+        </p:blipFill>
+        <p:spPr>
+          <a:xfrm>
+            <a:off x="7183988" y="4569132"/>
+            <a:ext cx="2071109" cy="1164999"/>
+          </a:xfrm>
+          <a:prstGeom prst="rect">
+            <a:avLst/>
+          </a:prstGeom>
+          <a:ln>
+            <a:solidFill>
+              <a:srgbClr val="C00000"/>
+            </a:solidFill>
+          </a:ln>
+        </p:spPr>
+      </p:pic>
+      <p:sp>
+        <p:nvSpPr>
+          <p:cNvPr id="10" name="Tekstfelt 9">
+            <a:extLst>
+              <a:ext uri="{FF2B5EF4-FFF2-40B4-BE49-F238E27FC236}">
+                <a16:creationId xmlns:a16="http://schemas.microsoft.com/office/drawing/2014/main" id="{E6DFD9FF-4F2C-77D3-96A9-978437627BA0}"/>
+              </a:ext>
+            </a:extLst>
+          </p:cNvPr>
+          <p:cNvSpPr txBox="1"/>
+          <p:nvPr/>
+        </p:nvSpPr>
+        <p:spPr>
+          <a:xfrm>
+            <a:off x="7030407" y="3984357"/>
+            <a:ext cx="2496998" cy="584775"/>
+          </a:xfrm>
+          <a:prstGeom prst="rect">
+            <a:avLst/>
+          </a:prstGeom>
+          <a:noFill/>
+        </p:spPr>
+        <p:txBody>
+          <a:bodyPr wrap="square" rtlCol="0">
+            <a:spAutoFit/>
+          </a:bodyPr>
+          <a:lstStyle/>
+          <a:p>
+            <a:r>
+              <a:rPr lang="da-DK" sz="1600" dirty="0"/>
+              <a:t>”</a:t>
+            </a:r>
+            <a:r>
+              <a:rPr lang="da-DK" sz="1600" dirty="0" err="1"/>
+              <a:t>Bucket</a:t>
+            </a:r>
+            <a:r>
+              <a:rPr lang="da-DK" sz="1600" dirty="0"/>
+              <a:t> </a:t>
+            </a:r>
+            <a:r>
+              <a:rPr lang="da-DK" sz="1600" dirty="0" err="1"/>
+              <a:t>fill</a:t>
+            </a:r>
+            <a:r>
+              <a:rPr lang="da-DK" sz="1600" dirty="0"/>
+              <a:t>” with </a:t>
+            </a:r>
+            <a:r>
+              <a:rPr lang="da-DK" sz="1600" dirty="0" err="1"/>
+              <a:t>white</a:t>
+            </a:r>
+            <a:r>
+              <a:rPr lang="da-DK" sz="1600" dirty="0"/>
+              <a:t> from a corner</a:t>
+            </a:r>
+          </a:p>
+        </p:txBody>
+      </p:sp>
+      <p:sp>
+        <p:nvSpPr>
+          <p:cNvPr id="11" name="Tekstfelt 10">
+            <a:extLst>
+              <a:ext uri="{FF2B5EF4-FFF2-40B4-BE49-F238E27FC236}">
+                <a16:creationId xmlns:a16="http://schemas.microsoft.com/office/drawing/2014/main" id="{09FB12B8-C213-8388-E2B2-0B4FB5C55E4E}"/>
+              </a:ext>
+            </a:extLst>
+          </p:cNvPr>
+          <p:cNvSpPr txBox="1"/>
+          <p:nvPr/>
+        </p:nvSpPr>
+        <p:spPr>
+          <a:xfrm>
+            <a:off x="2080232" y="3937838"/>
+            <a:ext cx="2816619" cy="861774"/>
+          </a:xfrm>
+          <a:prstGeom prst="rect">
+            <a:avLst/>
+          </a:prstGeom>
+          <a:noFill/>
+        </p:spPr>
+        <p:txBody>
+          <a:bodyPr wrap="square" rtlCol="0">
+            <a:spAutoFit/>
+          </a:bodyPr>
+          <a:lstStyle/>
+          <a:p>
+            <a:r>
+              <a:rPr lang="da-DK" sz="1600" dirty="0"/>
+              <a:t>Rendered cut </a:t>
+            </a:r>
+            <a:r>
+              <a:rPr lang="da-DK" sz="1600" dirty="0" err="1"/>
+              <a:t>section</a:t>
+            </a:r>
+            <a:endParaRPr lang="da-DK" sz="1600" dirty="0"/>
+          </a:p>
+          <a:p>
+            <a:r>
+              <a:rPr lang="da-DK" sz="1600" dirty="0"/>
+              <a:t>(red frame </a:t>
+            </a:r>
+            <a:r>
+              <a:rPr lang="da-DK" sz="1600" dirty="0" err="1"/>
+              <a:t>added</a:t>
+            </a:r>
+            <a:r>
+              <a:rPr lang="da-DK" sz="1600" dirty="0"/>
+              <a:t> for </a:t>
+            </a:r>
+            <a:r>
+              <a:rPr lang="da-DK" sz="1600" dirty="0" err="1"/>
+              <a:t>clarity</a:t>
+            </a:r>
+            <a:r>
+              <a:rPr lang="da-DK" sz="1600" dirty="0"/>
+              <a:t>)</a:t>
+            </a:r>
+          </a:p>
+          <a:p>
             <a:endParaRPr lang="da-DK" dirty="0"/>
           </a:p>
+        </p:txBody>
+      </p:sp>
+      <p:sp>
+        <p:nvSpPr>
+          <p:cNvPr id="12" name="Pil: højre 11">
+            <a:extLst>
+              <a:ext uri="{FF2B5EF4-FFF2-40B4-BE49-F238E27FC236}">
+                <a16:creationId xmlns:a16="http://schemas.microsoft.com/office/drawing/2014/main" id="{60BB14F0-B33C-CA05-FAEF-537075746A4B}"/>
+              </a:ext>
+            </a:extLst>
+          </p:cNvPr>
+          <p:cNvSpPr/>
+          <p:nvPr/>
+        </p:nvSpPr>
+        <p:spPr>
+          <a:xfrm>
+            <a:off x="4498581" y="5039700"/>
+            <a:ext cx="232753" cy="240089"/>
+          </a:xfrm>
+          <a:prstGeom prst="rightArrow">
+            <a:avLst/>
+          </a:prstGeom>
+          <a:solidFill>
+            <a:schemeClr val="bg2">
+              <a:lumMod val="75000"/>
+            </a:schemeClr>
+          </a:solidFill>
+          <a:ln>
+            <a:noFill/>
+          </a:ln>
+        </p:spPr>
+        <p:style>
+          <a:lnRef idx="2">
+            <a:schemeClr val="accent1">
+              <a:shade val="15000"/>
+            </a:schemeClr>
+          </a:lnRef>
+          <a:fillRef idx="1">
+            <a:schemeClr val="accent1"/>
+          </a:fillRef>
+          <a:effectRef idx="0">
+            <a:schemeClr val="accent1"/>
+          </a:effectRef>
+          <a:fontRef idx="minor">
+            <a:schemeClr val="lt1"/>
+          </a:fontRef>
+        </p:style>
+        <p:txBody>
+          <a:bodyPr rtlCol="0" anchor="ctr"/>
+          <a:lstStyle/>
           <a:p>
+            <a:pPr algn="ctr"/>
+            <a:endParaRPr lang="da-DK"/>
+          </a:p>
+        </p:txBody>
+      </p:sp>
+      <p:sp>
+        <p:nvSpPr>
+          <p:cNvPr id="13" name="Pil: højre 12">
+            <a:extLst>
+              <a:ext uri="{FF2B5EF4-FFF2-40B4-BE49-F238E27FC236}">
+                <a16:creationId xmlns:a16="http://schemas.microsoft.com/office/drawing/2014/main" id="{64069CFF-B8F4-4930-C895-A7970A41564E}"/>
+              </a:ext>
+            </a:extLst>
+          </p:cNvPr>
+          <p:cNvSpPr/>
+          <p:nvPr/>
+        </p:nvSpPr>
+        <p:spPr>
+          <a:xfrm>
+            <a:off x="6928002" y="5051581"/>
+            <a:ext cx="232753" cy="240089"/>
+          </a:xfrm>
+          <a:prstGeom prst="rightArrow">
+            <a:avLst/>
+          </a:prstGeom>
+          <a:solidFill>
+            <a:schemeClr val="bg2">
+              <a:lumMod val="75000"/>
+            </a:schemeClr>
+          </a:solidFill>
+          <a:ln>
+            <a:noFill/>
+          </a:ln>
+        </p:spPr>
+        <p:style>
+          <a:lnRef idx="2">
+            <a:schemeClr val="accent1">
+              <a:shade val="15000"/>
+            </a:schemeClr>
+          </a:lnRef>
+          <a:fillRef idx="1">
+            <a:schemeClr val="accent1"/>
+          </a:fillRef>
+          <a:effectRef idx="0">
+            <a:schemeClr val="accent1"/>
+          </a:effectRef>
+          <a:fontRef idx="minor">
+            <a:schemeClr val="lt1"/>
+          </a:fontRef>
+        </p:style>
+        <p:txBody>
+          <a:bodyPr rtlCol="0" anchor="ctr"/>
+          <a:lstStyle/>
+          <a:p>
+            <a:pPr algn="ctr"/>
+            <a:endParaRPr lang="da-DK"/>
+          </a:p>
+        </p:txBody>
+      </p:sp>
+      <p:sp>
+        <p:nvSpPr>
+          <p:cNvPr id="14" name="Tekstfelt 13">
+            <a:extLst>
+              <a:ext uri="{FF2B5EF4-FFF2-40B4-BE49-F238E27FC236}">
+                <a16:creationId xmlns:a16="http://schemas.microsoft.com/office/drawing/2014/main" id="{93A5B015-D2CC-8AA2-A11E-2667153A0ABB}"/>
+              </a:ext>
+            </a:extLst>
+          </p:cNvPr>
+          <p:cNvSpPr txBox="1"/>
+          <p:nvPr/>
+        </p:nvSpPr>
+        <p:spPr>
+          <a:xfrm>
+            <a:off x="1862172" y="6168921"/>
+            <a:ext cx="8215069" cy="369332"/>
+          </a:xfrm>
+          <a:prstGeom prst="rect">
+            <a:avLst/>
+          </a:prstGeom>
+          <a:noFill/>
+        </p:spPr>
+        <p:txBody>
+          <a:bodyPr wrap="none" rtlCol="0">
+            <a:spAutoFit/>
+          </a:bodyPr>
+          <a:lstStyle/>
+          <a:p>
             <a:r>
               <a:rPr lang="da-DK" dirty="0"/>
-              <a:t>This part </a:t>
+              <a:t>(</a:t>
             </a:r>
             <a:r>
               <a:rPr lang="da-DK" dirty="0" err="1"/>
-              <a:t>should</a:t>
+              <a:t>this</a:t>
+            </a:r>
+            <a:r>
+              <a:rPr lang="da-DK" dirty="0"/>
+              <a:t> is a bad </a:t>
+            </a:r>
+            <a:r>
+              <a:rPr lang="da-DK" dirty="0" err="1"/>
+              <a:t>example</a:t>
+            </a:r>
+            <a:r>
+              <a:rPr lang="da-DK" dirty="0"/>
+              <a:t>, </a:t>
+            </a:r>
+            <a:r>
+              <a:rPr lang="da-DK" dirty="0" err="1"/>
+              <a:t>because</a:t>
+            </a:r>
+            <a:r>
+              <a:rPr lang="da-DK" dirty="0"/>
+              <a:t> top/</a:t>
+            </a:r>
+            <a:r>
+              <a:rPr lang="da-DK" dirty="0" err="1"/>
+              <a:t>bottom</a:t>
             </a:r>
             <a:r>
               <a:rPr lang="da-DK" dirty="0"/>
@@ -47599,15 +48470,7 @@
             </a:r>
             <a:r>
               <a:rPr lang="da-DK" dirty="0" err="1"/>
-              <a:t>be</a:t>
-            </a:r>
-            <a:r>
-              <a:rPr lang="da-DK" dirty="0"/>
-              <a:t> irrelevant to </a:t>
-            </a:r>
-            <a:r>
-              <a:rPr lang="da-DK" dirty="0" err="1"/>
-              <a:t>competitors</a:t>
+              <a:t>visibility</a:t>
             </a:r>
             <a:r>
               <a:rPr lang="da-DK" dirty="0"/>
@@ -47615,7 +48478,7 @@
             </a:r>
             <a:r>
               <a:rPr lang="da-DK" dirty="0" err="1"/>
-              <a:t>that</a:t>
+              <a:t>doesn’t</a:t>
             </a:r>
             <a:r>
               <a:rPr lang="da-DK" dirty="0"/>
@@ -47623,27 +48486,11 @@
             </a:r>
             <a:r>
               <a:rPr lang="da-DK" dirty="0" err="1"/>
-              <a:t>don’t</a:t>
+              <a:t>apply</a:t>
             </a:r>
             <a:r>
               <a:rPr lang="da-DK" dirty="0"/>
-              <a:t> </a:t>
-            </a:r>
-            <a:r>
-              <a:rPr lang="da-DK" dirty="0" err="1"/>
-              <a:t>wish</a:t>
-            </a:r>
-            <a:r>
-              <a:rPr lang="da-DK" dirty="0"/>
-              <a:t> to </a:t>
-            </a:r>
-            <a:r>
-              <a:rPr lang="da-DK" dirty="0" err="1"/>
-              <a:t>contribute</a:t>
-            </a:r>
-            <a:r>
-              <a:rPr lang="da-DK" dirty="0"/>
-              <a:t> to the script.</a:t>
+              <a:t> to the wings…)</a:t>
             </a:r>
           </a:p>
         </p:txBody>
@@ -47651,7 +48498,7 @@
     </p:spTree>
     <p:extLst>
       <p:ext uri="{BB962C8B-B14F-4D97-AF65-F5344CB8AC3E}">
-        <p14:creationId xmlns:p14="http://schemas.microsoft.com/office/powerpoint/2010/main" val="2522301294"/>
+        <p14:creationId xmlns:p14="http://schemas.microsoft.com/office/powerpoint/2010/main" val="1368633886"/>
       </p:ext>
     </p:extLst>
   </p:cSld>

</xml_diff>